<commit_message>
Present Schema for judges and add reproducible TinyFish draft workflow
Rewrite project documentation and submission copy for their audience. Preserve the visual style and original artwork. Add explicit live and recorded CLI workflows, approved-fact persistence coverage, and source notes in both decks. Remove internal handover files from the public submission.
</commit_message>
<xml_diff>
--- a/submission/Schema_Kritical_Round1.pptx
+++ b/submission/Schema_Kritical_Round1.pptx
@@ -2,20 +2,20 @@
 <file path=ppt/presentation.xml><?xml version="1.0" encoding="utf-8"?>
 <p:presentation xmlns:p="http://schemas.openxmlformats.org/presentationml/2006/main">
   <p:sldMasterIdLst>
-    <p:sldMasterId xmlns:r="http://schemas.openxmlformats.org/officeDocument/2006/relationships" id="2147483648" r:id="R5334eee68904475e"/>
+    <p:sldMasterId xmlns:r="http://schemas.openxmlformats.org/officeDocument/2006/relationships" id="2147483648" r:id="R685d403297e3468f"/>
   </p:sldMasterIdLst>
   <p:notesMasterIdLst>
-    <p:notesMasterId xmlns:r="http://schemas.openxmlformats.org/officeDocument/2006/relationships" r:id="Rf5916e2989754adf"/>
+    <p:notesMasterId xmlns:r="http://schemas.openxmlformats.org/officeDocument/2006/relationships" r:id="R82ae66d84cb248cd"/>
   </p:notesMasterIdLst>
   <p:sldIdLst>
-    <p:sldId xmlns:r="http://schemas.openxmlformats.org/officeDocument/2006/relationships" id="256" r:id="R8b9573ae3be14e22"/>
-    <p:sldId xmlns:r="http://schemas.openxmlformats.org/officeDocument/2006/relationships" id="257" r:id="R7eeee1f2d49141bf"/>
-    <p:sldId xmlns:r="http://schemas.openxmlformats.org/officeDocument/2006/relationships" id="258" r:id="R0a7d7e46ba8f46b9"/>
-    <p:sldId xmlns:r="http://schemas.openxmlformats.org/officeDocument/2006/relationships" id="259" r:id="Ra653a29dde1a4b5a"/>
-    <p:sldId xmlns:r="http://schemas.openxmlformats.org/officeDocument/2006/relationships" id="260" r:id="R9ad1cb8c05284f62"/>
-    <p:sldId xmlns:r="http://schemas.openxmlformats.org/officeDocument/2006/relationships" id="261" r:id="R7919f87b37a4479b"/>
-    <p:sldId xmlns:r="http://schemas.openxmlformats.org/officeDocument/2006/relationships" id="262" r:id="R466f1db4d9ab4a6d"/>
-    <p:sldId xmlns:r="http://schemas.openxmlformats.org/officeDocument/2006/relationships" id="263" r:id="R31716f1d841e4a66"/>
+    <p:sldId xmlns:r="http://schemas.openxmlformats.org/officeDocument/2006/relationships" id="256" r:id="Rc743ebbac7f44654"/>
+    <p:sldId xmlns:r="http://schemas.openxmlformats.org/officeDocument/2006/relationships" id="257" r:id="R8d3df75ad22c4232"/>
+    <p:sldId xmlns:r="http://schemas.openxmlformats.org/officeDocument/2006/relationships" id="258" r:id="R0560014e21e4499e"/>
+    <p:sldId xmlns:r="http://schemas.openxmlformats.org/officeDocument/2006/relationships" id="259" r:id="Rc3e18f494af84d68"/>
+    <p:sldId xmlns:r="http://schemas.openxmlformats.org/officeDocument/2006/relationships" id="260" r:id="R9b15f6415dba49c5"/>
+    <p:sldId xmlns:r="http://schemas.openxmlformats.org/officeDocument/2006/relationships" id="261" r:id="R722b3d2a834248ae"/>
+    <p:sldId xmlns:r="http://schemas.openxmlformats.org/officeDocument/2006/relationships" id="262" r:id="R99bb9871db26401d"/>
+    <p:sldId xmlns:r="http://schemas.openxmlformats.org/officeDocument/2006/relationships" id="263" r:id="R96f0baf0077a45a2"/>
   </p:sldIdLst>
   <p:sldSz cx="9144000" cy="5143500"/>
   <p:notesSz cx="6858000" cy="9144000"/>
@@ -449,7 +449,7 @@
           <a:lstStyle xmlns:a="http://schemas.openxmlformats.org/drawingml/2006/main"/>
           <a:p xmlns:a="http://schemas.openxmlformats.org/drawingml/2006/main">
             <a:r>
-              <a:t>Kritical adaptation of the supplied AZINHACK deck. Original handcrafted illustration preserved. Team roster follows the supplied HackIIITD team deck and needs final registration confirmation. Current prototype and future commercial plans are distinguished throughout.</a:t>
+              <a:t>Schema preserves the story behind a photo. The user writes the personal note and approves any public event details before they enter the journal. The Kritical prototype uses TinyFish for that event-research step.</a:t>
             </a:r>
           </a:p>
         </p:txBody>
@@ -519,7 +519,7 @@
           <a:lstStyle xmlns:a="http://schemas.openxmlformats.org/drawingml/2006/main"/>
           <a:p xmlns:a="http://schemas.openxmlformats.org/drawingml/2006/main">
             <a:r>
-              <a:t>Audience and product motivation come from the supplied Schema blueprint and founder story. The pilot is proposed, not completed. No survey, retention or memory-loss statistic is claimed.</a:t>
+              <a:t>Our initial audience is adults aged 18–30 who want a private record of their lives. We propose a 20-person adult pilot to measure capture and revisits. This is a target, not completed research.</a:t>
             </a:r>
           </a:p>
         </p:txBody>
@@ -589,7 +589,7 @@
           <a:lstStyle xmlns:a="http://schemas.openxmlformats.org/drawingml/2006/main"/>
           <a:p xmlns:a="http://schemas.openxmlformats.org/drawingml/2006/main">
             <a:r>
-              <a:t>The courtyard gig is explicitly an illustrative example from the supplied deck. It is not a real user testimonial or a TinyFish provider result.</a:t>
+              <a:t>The courtyard gig is an illustrative journal page. A personal note and public event context have different sources. The user chooses what to include, then edits and saves the page.</a:t>
             </a:r>
           </a:p>
         </p:txBody>
@@ -939,7 +939,7 @@
           <a:lstStyle xmlns:a="http://schemas.openxmlformats.org/drawingml/2006/main"/>
           <a:p xmlns:a="http://schemas.openxmlformats.org/drawingml/2006/main">
             <a:r>
-              <a:t>Names and roles come from the supplied LineOfCode HackIIITD deck. Confirm the Kritical registration roster before submitting. 85 tests means the original 81 plus three provider/draft-boundary tests and one journal save/reopen integration test added in this copy. Real customer-host login, configured TinyFish API request and save/reopen still need live acceptance. Mobile and stronger semantic retrieval are future scope.</a:t>
+              <a:t>The prototype includes journal editing, the life archive and TinyFish fact review. The automated suite covers core services, provider boundaries and reviewed-draft persistence, including an explicit recorded-result CLI reproduction. The five-step result is a live provider extraction, not a hosted-account acceptance test. Next, an opt-in adult pilot will test capture and revisits. Native mobile and semantic memory threads are future work.</a:t>
             </a:r>
           </a:p>
         </p:txBody>
@@ -986,7 +986,7 @@
           <p:cNvPr id="3" name="Title">
             <a:extLst xmlns:a="http://schemas.openxmlformats.org/drawingml/2006/main">
               <a:ext uri="{FF2B5EF4-FFF2-40B4-BE49-F238E27FC236}">
-                <a16:creationId xmlns:a16="http://schemas.microsoft.com/office/drawing/2014/main" id="{21A5D6FD-4B73-4190-A118-1AC4BF9A3D7B}"/>
+                <a16:creationId xmlns:a16="http://schemas.microsoft.com/office/drawing/2014/main" id="{7B3E9270-2A7A-48DA-8538-A2B5ADE07904}"/>
               </a:ext>
             </a:extLst>
           </p:cNvPr>
@@ -1215,7 +1215,7 @@
           <p:cNvPr id="2" name="Subtitle">
             <a:extLst xmlns:a="http://schemas.openxmlformats.org/drawingml/2006/main">
               <a:ext uri="{FF2B5EF4-FFF2-40B4-BE49-F238E27FC236}">
-                <a16:creationId xmlns:a16="http://schemas.microsoft.com/office/drawing/2014/main" id="{4FB744E1-7CE6-4E87-A2FB-CFFFFC4CDCEA}"/>
+                <a16:creationId xmlns:a16="http://schemas.microsoft.com/office/drawing/2014/main" id="{2D9583D7-42E6-4924-B078-434AED92BF3E}"/>
               </a:ext>
             </a:extLst>
           </p:cNvPr>
@@ -1461,7 +1461,7 @@
           <p:cNvPr id="2" name="Section title">
             <a:extLst xmlns:a="http://schemas.openxmlformats.org/drawingml/2006/main">
               <a:ext uri="{FF2B5EF4-FFF2-40B4-BE49-F238E27FC236}">
-                <a16:creationId xmlns:a16="http://schemas.microsoft.com/office/drawing/2014/main" id="{1D335FB5-08DC-4740-888C-96BCD03E8930}"/>
+                <a16:creationId xmlns:a16="http://schemas.microsoft.com/office/drawing/2014/main" id="{DD780D00-EA57-4073-A8BF-C75BA1F9F591}"/>
               </a:ext>
             </a:extLst>
           </p:cNvPr>
@@ -1707,7 +1707,7 @@
           <p:cNvPr id="3" name="Title">
             <a:extLst xmlns:a="http://schemas.openxmlformats.org/drawingml/2006/main">
               <a:ext uri="{FF2B5EF4-FFF2-40B4-BE49-F238E27FC236}">
-                <a16:creationId xmlns:a16="http://schemas.microsoft.com/office/drawing/2014/main" id="{0A76CD32-2CB5-4A83-9CE0-4526DDEB08F2}"/>
+                <a16:creationId xmlns:a16="http://schemas.microsoft.com/office/drawing/2014/main" id="{4E0D5C8A-72F1-432E-A392-2D0ACE342C3E}"/>
               </a:ext>
             </a:extLst>
           </p:cNvPr>
@@ -1936,7 +1936,7 @@
           <p:cNvPr id="2" name="Body">
             <a:extLst xmlns:a="http://schemas.openxmlformats.org/drawingml/2006/main">
               <a:ext uri="{FF2B5EF4-FFF2-40B4-BE49-F238E27FC236}">
-                <a16:creationId xmlns:a16="http://schemas.microsoft.com/office/drawing/2014/main" id="{4B7161F2-92F7-4648-BE61-487CFF0CD743}"/>
+                <a16:creationId xmlns:a16="http://schemas.microsoft.com/office/drawing/2014/main" id="{9EB450B7-1D4B-4CE7-814B-6A9B80D27BF0}"/>
               </a:ext>
             </a:extLst>
           </p:cNvPr>
@@ -2182,7 +2182,7 @@
           <p:cNvPr id="4" name="Title">
             <a:extLst xmlns:a="http://schemas.openxmlformats.org/drawingml/2006/main">
               <a:ext uri="{FF2B5EF4-FFF2-40B4-BE49-F238E27FC236}">
-                <a16:creationId xmlns:a16="http://schemas.microsoft.com/office/drawing/2014/main" id="{C66451B4-451C-41D4-866B-F25CC2385595}"/>
+                <a16:creationId xmlns:a16="http://schemas.microsoft.com/office/drawing/2014/main" id="{4E65E83E-7DAB-473B-AE19-86108F2D57A1}"/>
               </a:ext>
             </a:extLst>
           </p:cNvPr>
@@ -2411,7 +2411,7 @@
           <p:cNvPr id="2" name="Left column">
             <a:extLst xmlns:a="http://schemas.openxmlformats.org/drawingml/2006/main">
               <a:ext uri="{FF2B5EF4-FFF2-40B4-BE49-F238E27FC236}">
-                <a16:creationId xmlns:a16="http://schemas.microsoft.com/office/drawing/2014/main" id="{DE87E054-6F03-49D2-8733-F6D0EC161A3F}"/>
+                <a16:creationId xmlns:a16="http://schemas.microsoft.com/office/drawing/2014/main" id="{BEC45B15-C4A1-4D4B-8EC4-EB26852BE54A}"/>
               </a:ext>
             </a:extLst>
           </p:cNvPr>
@@ -2640,7 +2640,7 @@
           <p:cNvPr id="3" name="Right column">
             <a:extLst xmlns:a="http://schemas.openxmlformats.org/drawingml/2006/main">
               <a:ext uri="{FF2B5EF4-FFF2-40B4-BE49-F238E27FC236}">
-                <a16:creationId xmlns:a16="http://schemas.microsoft.com/office/drawing/2014/main" id="{C12E8253-327F-417B-A02A-1355F76278ED}"/>
+                <a16:creationId xmlns:a16="http://schemas.microsoft.com/office/drawing/2014/main" id="{DBF9B33B-77D2-4736-85DB-795B74E18FDE}"/>
               </a:ext>
             </a:extLst>
           </p:cNvPr>
@@ -2886,7 +2886,7 @@
           <p:cNvPr id="3" name="Title">
             <a:extLst xmlns:a="http://schemas.openxmlformats.org/drawingml/2006/main">
               <a:ext uri="{FF2B5EF4-FFF2-40B4-BE49-F238E27FC236}">
-                <a16:creationId xmlns:a16="http://schemas.microsoft.com/office/drawing/2014/main" id="{A5386C33-2ADA-40F2-BED4-6CD36EC0633E}"/>
+                <a16:creationId xmlns:a16="http://schemas.microsoft.com/office/drawing/2014/main" id="{ED637EBC-813A-4B5B-A4DD-AB84849FE027}"/>
               </a:ext>
             </a:extLst>
           </p:cNvPr>
@@ -3115,7 +3115,7 @@
           <p:cNvPr id="2" name="Left column">
             <a:extLst xmlns:a="http://schemas.openxmlformats.org/drawingml/2006/main">
               <a:ext uri="{FF2B5EF4-FFF2-40B4-BE49-F238E27FC236}">
-                <a16:creationId xmlns:a16="http://schemas.microsoft.com/office/drawing/2014/main" id="{9B5FA027-EF6A-451A-809F-CF3193F7CDBD}"/>
+                <a16:creationId xmlns:a16="http://schemas.microsoft.com/office/drawing/2014/main" id="{3C1EEE60-7D9F-49E6-81B0-262810F4DAF1}"/>
               </a:ext>
             </a:extLst>
           </p:cNvPr>
@@ -3382,12 +3382,12 @@
   </p:cSld>
   <p:clrMap bg1="lt1" tx1="dk1" bg2="lt2" tx2="dk2" accent1="accent1" accent2="accent2" accent3="accent3" accent4="accent4" accent5="accent5" accent6="accent6" hlink="hlink" folHlink="folHlink"/>
   <p:sldLayoutIdLst>
-    <p:sldLayoutId xmlns:r="http://schemas.openxmlformats.org/officeDocument/2006/relationships" id="2147483649" r:id="Rd1aae4834b294639"/>
-    <p:sldLayoutId xmlns:r="http://schemas.openxmlformats.org/officeDocument/2006/relationships" id="2147483650" r:id="R1e1b66e9d11843d7"/>
-    <p:sldLayoutId xmlns:r="http://schemas.openxmlformats.org/officeDocument/2006/relationships" id="2147483651" r:id="Rbe9f03ab5a1b4004"/>
-    <p:sldLayoutId xmlns:r="http://schemas.openxmlformats.org/officeDocument/2006/relationships" id="2147483652" r:id="R75050b5896c0435e"/>
-    <p:sldLayoutId xmlns:r="http://schemas.openxmlformats.org/officeDocument/2006/relationships" id="2147483653" r:id="Rf66c3e8fcf074cae"/>
-    <p:sldLayoutId xmlns:r="http://schemas.openxmlformats.org/officeDocument/2006/relationships" id="2147483654" r:id="Rf6e2a5881c144493"/>
+    <p:sldLayoutId xmlns:r="http://schemas.openxmlformats.org/officeDocument/2006/relationships" id="2147483649" r:id="R047f628595264a3a"/>
+    <p:sldLayoutId xmlns:r="http://schemas.openxmlformats.org/officeDocument/2006/relationships" id="2147483650" r:id="R55202d0e10244552"/>
+    <p:sldLayoutId xmlns:r="http://schemas.openxmlformats.org/officeDocument/2006/relationships" id="2147483651" r:id="R9e0dc27aef77475f"/>
+    <p:sldLayoutId xmlns:r="http://schemas.openxmlformats.org/officeDocument/2006/relationships" id="2147483652" r:id="Ra387af877615470a"/>
+    <p:sldLayoutId xmlns:r="http://schemas.openxmlformats.org/officeDocument/2006/relationships" id="2147483653" r:id="Ra3b374a3ddd04364"/>
+    <p:sldLayoutId xmlns:r="http://schemas.openxmlformats.org/officeDocument/2006/relationships" id="2147483654" r:id="R26d5fff445da4688"/>
   </p:sldLayoutIdLst>
   <p:txStyles>
     <p:titleStyle>
@@ -3938,7 +3938,7 @@
           <p:cNvPr id="7" name="element-1">
             <a:extLst xmlns:a="http://schemas.openxmlformats.org/drawingml/2006/main">
               <a:ext uri="{FF2B5EF4-FFF2-40B4-BE49-F238E27FC236}">
-                <a16:creationId xmlns:a16="http://schemas.microsoft.com/office/drawing/2014/main" id="{0689EDE1-D38C-4B82-8433-634618921327}"/>
+                <a16:creationId xmlns:a16="http://schemas.microsoft.com/office/drawing/2014/main" id="{E629CECF-1A17-41FC-9FB9-434398A655DC}"/>
               </a:ext>
             </a:extLst>
           </p:cNvPr>
@@ -4097,7 +4097,7 @@
           <p:cNvPr id="2" name="element-2">
             <a:extLst xmlns:a="http://schemas.openxmlformats.org/drawingml/2006/main">
               <a:ext uri="{FF2B5EF4-FFF2-40B4-BE49-F238E27FC236}">
-                <a16:creationId xmlns:a16="http://schemas.microsoft.com/office/drawing/2014/main" id="{3ADFE0DB-5D9A-45B5-AA5E-97B56E417A2B}"/>
+                <a16:creationId xmlns:a16="http://schemas.microsoft.com/office/drawing/2014/main" id="{51AE9B81-A303-4324-83FA-DFC69EEDF790}"/>
               </a:ext>
             </a:extLst>
           </p:cNvPr>
@@ -4302,7 +4302,7 @@
           <p:cNvPr id="3" name="element-3">
             <a:extLst xmlns:a="http://schemas.openxmlformats.org/drawingml/2006/main">
               <a:ext uri="{FF2B5EF4-FFF2-40B4-BE49-F238E27FC236}">
-                <a16:creationId xmlns:a16="http://schemas.microsoft.com/office/drawing/2014/main" id="{7639AD2C-8A36-4DE8-A7CD-AE54F24252CA}"/>
+                <a16:creationId xmlns:a16="http://schemas.microsoft.com/office/drawing/2014/main" id="{D9634406-C870-41A3-B999-5B25852F3585}"/>
               </a:ext>
             </a:extLst>
           </p:cNvPr>
@@ -4461,7 +4461,7 @@
           <p:cNvPr id="4" name="">
             <a:extLst xmlns:a="http://schemas.openxmlformats.org/drawingml/2006/main">
               <a:ext uri="{FF2B5EF4-FFF2-40B4-BE49-F238E27FC236}">
-                <a16:creationId xmlns:a16="http://schemas.microsoft.com/office/drawing/2014/main" id="{1EE88FF0-D0A0-4E4D-8F80-B637E6D1A689}"/>
+                <a16:creationId xmlns:a16="http://schemas.microsoft.com/office/drawing/2014/main" id="{A78CE281-36E3-412D-8922-0398B3EBD01B}"/>
               </a:ext>
             </a:extLst>
           </p:cNvPr>
@@ -4471,7 +4471,7 @@
           <p:nvPr/>
         </p:nvPicPr>
         <p:blipFill>
-          <a:blip xmlns:r="http://schemas.openxmlformats.org/officeDocument/2006/relationships" xmlns:a="http://schemas.openxmlformats.org/drawingml/2006/main" r:embed="R94f506828fd7413d"/>
+          <a:blip xmlns:r="http://schemas.openxmlformats.org/officeDocument/2006/relationships" xmlns:a="http://schemas.openxmlformats.org/drawingml/2006/main" r:embed="R5707a31b440a400e"/>
           <a:stretch xmlns:a="http://schemas.openxmlformats.org/drawingml/2006/main"/>
         </p:blipFill>
         <p:spPr>
@@ -4489,7 +4489,7 @@
           <p:cNvPr id="5" name="element-4">
             <a:extLst xmlns:a="http://schemas.openxmlformats.org/drawingml/2006/main">
               <a:ext uri="{FF2B5EF4-FFF2-40B4-BE49-F238E27FC236}">
-                <a16:creationId xmlns:a16="http://schemas.microsoft.com/office/drawing/2014/main" id="{C9727D6A-351F-49DB-9513-FE486694C86F}"/>
+                <a16:creationId xmlns:a16="http://schemas.microsoft.com/office/drawing/2014/main" id="{88C05DE0-6887-4A5D-97C5-A14E64943FE4}"/>
               </a:ext>
             </a:extLst>
           </p:cNvPr>
@@ -4648,7 +4648,7 @@
           <p:cNvPr id="6" name="element-5">
             <a:extLst xmlns:a="http://schemas.openxmlformats.org/drawingml/2006/main">
               <a:ext uri="{FF2B5EF4-FFF2-40B4-BE49-F238E27FC236}">
-                <a16:creationId xmlns:a16="http://schemas.microsoft.com/office/drawing/2014/main" id="{2024BAE7-6CE5-4FF9-A394-E90F680FB903}"/>
+                <a16:creationId xmlns:a16="http://schemas.microsoft.com/office/drawing/2014/main" id="{01AADD68-4DD5-4003-9EE7-A3487CCB92E7}"/>
               </a:ext>
             </a:extLst>
           </p:cNvPr>
@@ -4805,7 +4805,7 @@
     </p:spTree>
     <p:extLst>
       <p:ext uri="{BB962C8B-B14F-4D97-AF65-F5344CB8AC3E}">
-        <p14:creationId xmlns:p14="http://schemas.microsoft.com/office/powerpoint/2010/main" val="1605728108"/>
+        <p14:creationId xmlns:p14="http://schemas.microsoft.com/office/powerpoint/2010/main" val="2106701383"/>
       </p:ext>
     </p:extLst>
   </p:cSld>
@@ -4836,7 +4836,7 @@
           <p:cNvPr id="18" name="element-6">
             <a:extLst xmlns:a="http://schemas.openxmlformats.org/drawingml/2006/main">
               <a:ext uri="{FF2B5EF4-FFF2-40B4-BE49-F238E27FC236}">
-                <a16:creationId xmlns:a16="http://schemas.microsoft.com/office/drawing/2014/main" id="{4599C1AB-EF76-47F6-9AB6-F73A97A7B3FD}"/>
+                <a16:creationId xmlns:a16="http://schemas.microsoft.com/office/drawing/2014/main" id="{4B2F4F85-C51B-418A-AC73-4D6622901DD5}"/>
               </a:ext>
             </a:extLst>
           </p:cNvPr>
@@ -5018,7 +5018,7 @@
           <p:cNvPr id="2" name="element-7">
             <a:extLst xmlns:a="http://schemas.openxmlformats.org/drawingml/2006/main">
               <a:ext uri="{FF2B5EF4-FFF2-40B4-BE49-F238E27FC236}">
-                <a16:creationId xmlns:a16="http://schemas.microsoft.com/office/drawing/2014/main" id="{59A1B825-75F5-489B-80D3-E7A186068633}"/>
+                <a16:creationId xmlns:a16="http://schemas.microsoft.com/office/drawing/2014/main" id="{F205275E-1D61-430B-8D88-310B969DECE2}"/>
               </a:ext>
             </a:extLst>
           </p:cNvPr>
@@ -5177,7 +5177,7 @@
           <p:cNvPr id="3" name="element-8">
             <a:extLst xmlns:a="http://schemas.openxmlformats.org/drawingml/2006/main">
               <a:ext uri="{FF2B5EF4-FFF2-40B4-BE49-F238E27FC236}">
-                <a16:creationId xmlns:a16="http://schemas.microsoft.com/office/drawing/2014/main" id="{79989B03-2D42-42A9-A077-5251850F66E4}"/>
+                <a16:creationId xmlns:a16="http://schemas.microsoft.com/office/drawing/2014/main" id="{843DB34A-4C59-41F2-AF6D-598E926BAFA7}"/>
               </a:ext>
             </a:extLst>
           </p:cNvPr>
@@ -5208,7 +5208,7 @@
           <p:cNvPr id="4" name="element-9">
             <a:extLst xmlns:a="http://schemas.openxmlformats.org/drawingml/2006/main">
               <a:ext uri="{FF2B5EF4-FFF2-40B4-BE49-F238E27FC236}">
-                <a16:creationId xmlns:a16="http://schemas.microsoft.com/office/drawing/2014/main" id="{07FAD6B4-2FD0-44E4-8EA3-FC96749C0567}"/>
+                <a16:creationId xmlns:a16="http://schemas.microsoft.com/office/drawing/2014/main" id="{844F9845-F38C-4EEC-9253-779F4905C019}"/>
               </a:ext>
             </a:extLst>
           </p:cNvPr>
@@ -5367,7 +5367,7 @@
           <p:cNvPr id="5" name="element-10">
             <a:extLst xmlns:a="http://schemas.openxmlformats.org/drawingml/2006/main">
               <a:ext uri="{FF2B5EF4-FFF2-40B4-BE49-F238E27FC236}">
-                <a16:creationId xmlns:a16="http://schemas.microsoft.com/office/drawing/2014/main" id="{12071EDC-7513-4AAC-9BA4-F8FA0C6C9EA0}"/>
+                <a16:creationId xmlns:a16="http://schemas.microsoft.com/office/drawing/2014/main" id="{E7AEEA20-DFDA-4491-86EC-4789F7ECE24F}"/>
               </a:ext>
             </a:extLst>
           </p:cNvPr>
@@ -5398,7 +5398,7 @@
           <p:cNvPr id="6" name="element-11">
             <a:extLst xmlns:a="http://schemas.openxmlformats.org/drawingml/2006/main">
               <a:ext uri="{FF2B5EF4-FFF2-40B4-BE49-F238E27FC236}">
-                <a16:creationId xmlns:a16="http://schemas.microsoft.com/office/drawing/2014/main" id="{F484327F-35A6-4BC9-8F6E-DFA57593C742}"/>
+                <a16:creationId xmlns:a16="http://schemas.microsoft.com/office/drawing/2014/main" id="{86F00A9E-B3AA-4E36-9575-43BCF0AF4C69}"/>
               </a:ext>
             </a:extLst>
           </p:cNvPr>
@@ -5557,7 +5557,7 @@
           <p:cNvPr id="7" name="element-12">
             <a:extLst xmlns:a="http://schemas.openxmlformats.org/drawingml/2006/main">
               <a:ext uri="{FF2B5EF4-FFF2-40B4-BE49-F238E27FC236}">
-                <a16:creationId xmlns:a16="http://schemas.microsoft.com/office/drawing/2014/main" id="{CD76321B-1CAE-441C-A092-AE99E3F29EDC}"/>
+                <a16:creationId xmlns:a16="http://schemas.microsoft.com/office/drawing/2014/main" id="{0C668656-59FD-4637-AB29-FDF98A9A8AC5}"/>
               </a:ext>
             </a:extLst>
           </p:cNvPr>
@@ -5588,7 +5588,7 @@
           <p:cNvPr id="8" name="element-13">
             <a:extLst xmlns:a="http://schemas.openxmlformats.org/drawingml/2006/main">
               <a:ext uri="{FF2B5EF4-FFF2-40B4-BE49-F238E27FC236}">
-                <a16:creationId xmlns:a16="http://schemas.microsoft.com/office/drawing/2014/main" id="{B0798427-F44D-489C-B10A-30302CE30683}"/>
+                <a16:creationId xmlns:a16="http://schemas.microsoft.com/office/drawing/2014/main" id="{F61300B9-5400-410A-BF57-1ADA2C8AE880}"/>
               </a:ext>
             </a:extLst>
           </p:cNvPr>
@@ -5747,7 +5747,7 @@
           <p:cNvPr id="9" name="element-14">
             <a:extLst xmlns:a="http://schemas.openxmlformats.org/drawingml/2006/main">
               <a:ext uri="{FF2B5EF4-FFF2-40B4-BE49-F238E27FC236}">
-                <a16:creationId xmlns:a16="http://schemas.microsoft.com/office/drawing/2014/main" id="{D494BD8A-741E-40F7-9C44-A02D182AA491}"/>
+                <a16:creationId xmlns:a16="http://schemas.microsoft.com/office/drawing/2014/main" id="{04F4A947-E346-4F5D-B73D-08BEFD1603DC}"/>
               </a:ext>
             </a:extLst>
           </p:cNvPr>
@@ -5778,7 +5778,7 @@
           <p:cNvPr id="10" name="element-15">
             <a:extLst xmlns:a="http://schemas.openxmlformats.org/drawingml/2006/main">
               <a:ext uri="{FF2B5EF4-FFF2-40B4-BE49-F238E27FC236}">
-                <a16:creationId xmlns:a16="http://schemas.microsoft.com/office/drawing/2014/main" id="{29DC86BA-4E27-4932-8C23-352437FA3422}"/>
+                <a16:creationId xmlns:a16="http://schemas.microsoft.com/office/drawing/2014/main" id="{EE8656AA-8BD2-4046-BEE6-89554F7C44A5}"/>
               </a:ext>
             </a:extLst>
           </p:cNvPr>
@@ -5960,7 +5960,7 @@
           <p:cNvPr id="11" name="element-16">
             <a:extLst xmlns:a="http://schemas.openxmlformats.org/drawingml/2006/main">
               <a:ext uri="{FF2B5EF4-FFF2-40B4-BE49-F238E27FC236}">
-                <a16:creationId xmlns:a16="http://schemas.microsoft.com/office/drawing/2014/main" id="{39CD0851-F1A1-43E4-A1D6-4074EAF95D25}"/>
+                <a16:creationId xmlns:a16="http://schemas.microsoft.com/office/drawing/2014/main" id="{047EBF9E-7F23-4EF3-9DD8-3E45271B21E7}"/>
               </a:ext>
             </a:extLst>
           </p:cNvPr>
@@ -6119,7 +6119,7 @@
           <p:cNvPr id="12" name="element-17">
             <a:extLst xmlns:a="http://schemas.openxmlformats.org/drawingml/2006/main">
               <a:ext uri="{FF2B5EF4-FFF2-40B4-BE49-F238E27FC236}">
-                <a16:creationId xmlns:a16="http://schemas.microsoft.com/office/drawing/2014/main" id="{110FA057-94F9-46B0-B7FC-AAC4F1897178}"/>
+                <a16:creationId xmlns:a16="http://schemas.microsoft.com/office/drawing/2014/main" id="{C3145D9F-F947-471B-8946-210D3E2194B8}"/>
               </a:ext>
             </a:extLst>
           </p:cNvPr>
@@ -6278,7 +6278,7 @@
           <p:cNvPr id="13" name="element-18">
             <a:extLst xmlns:a="http://schemas.openxmlformats.org/drawingml/2006/main">
               <a:ext uri="{FF2B5EF4-FFF2-40B4-BE49-F238E27FC236}">
-                <a16:creationId xmlns:a16="http://schemas.microsoft.com/office/drawing/2014/main" id="{359490FE-136A-4A2C-82D7-76704FCD1B82}"/>
+                <a16:creationId xmlns:a16="http://schemas.microsoft.com/office/drawing/2014/main" id="{F4403268-495B-4749-AF58-7EED07028C0C}"/>
               </a:ext>
             </a:extLst>
           </p:cNvPr>
@@ -6311,7 +6311,7 @@
           <p:cNvPr id="14" name="element-19">
             <a:extLst xmlns:a="http://schemas.openxmlformats.org/drawingml/2006/main">
               <a:ext uri="{FF2B5EF4-FFF2-40B4-BE49-F238E27FC236}">
-                <a16:creationId xmlns:a16="http://schemas.microsoft.com/office/drawing/2014/main" id="{896AED90-AAA2-4D14-8DA2-61D7F6B2BB3F}"/>
+                <a16:creationId xmlns:a16="http://schemas.microsoft.com/office/drawing/2014/main" id="{0C086D80-66BC-4F54-9EF9-6F852F605626}"/>
               </a:ext>
             </a:extLst>
           </p:cNvPr>
@@ -6470,7 +6470,7 @@
           <p:cNvPr id="15" name="element-20">
             <a:extLst xmlns:a="http://schemas.openxmlformats.org/drawingml/2006/main">
               <a:ext uri="{FF2B5EF4-FFF2-40B4-BE49-F238E27FC236}">
-                <a16:creationId xmlns:a16="http://schemas.microsoft.com/office/drawing/2014/main" id="{646C2E34-CDC2-4505-8C58-E824593927FE}"/>
+                <a16:creationId xmlns:a16="http://schemas.microsoft.com/office/drawing/2014/main" id="{05F00F70-2A7A-4943-B278-496F12E2ED76}"/>
               </a:ext>
             </a:extLst>
           </p:cNvPr>
@@ -6629,7 +6629,7 @@
           <p:cNvPr id="16" name="element-21">
             <a:extLst xmlns:a="http://schemas.openxmlformats.org/drawingml/2006/main">
               <a:ext uri="{FF2B5EF4-FFF2-40B4-BE49-F238E27FC236}">
-                <a16:creationId xmlns:a16="http://schemas.microsoft.com/office/drawing/2014/main" id="{457E6EEF-0A5F-4459-8B34-177E2AF486DE}"/>
+                <a16:creationId xmlns:a16="http://schemas.microsoft.com/office/drawing/2014/main" id="{B4E2CD46-8EB0-4306-8A48-8DB1E99A8197}"/>
               </a:ext>
             </a:extLst>
           </p:cNvPr>
@@ -6788,7 +6788,7 @@
           <p:cNvPr id="17" name="element-22">
             <a:extLst xmlns:a="http://schemas.openxmlformats.org/drawingml/2006/main">
               <a:ext uri="{FF2B5EF4-FFF2-40B4-BE49-F238E27FC236}">
-                <a16:creationId xmlns:a16="http://schemas.microsoft.com/office/drawing/2014/main" id="{7F6A28FC-8E5E-44E5-A040-E09234CB3442}"/>
+                <a16:creationId xmlns:a16="http://schemas.microsoft.com/office/drawing/2014/main" id="{277CA4C2-2FC9-4DBB-A4C0-170B5AA925F9}"/>
               </a:ext>
             </a:extLst>
           </p:cNvPr>
@@ -6945,7 +6945,7 @@
     </p:spTree>
     <p:extLst>
       <p:ext uri="{BB962C8B-B14F-4D97-AF65-F5344CB8AC3E}">
-        <p14:creationId xmlns:p14="http://schemas.microsoft.com/office/powerpoint/2010/main" val="720308541"/>
+        <p14:creationId xmlns:p14="http://schemas.microsoft.com/office/powerpoint/2010/main" val="248305110"/>
       </p:ext>
     </p:extLst>
   </p:cSld>
@@ -6976,7 +6976,7 @@
           <p:cNvPr id="15" name="element-23">
             <a:extLst xmlns:a="http://schemas.openxmlformats.org/drawingml/2006/main">
               <a:ext uri="{FF2B5EF4-FFF2-40B4-BE49-F238E27FC236}">
-                <a16:creationId xmlns:a16="http://schemas.microsoft.com/office/drawing/2014/main" id="{FE86EA6F-9F7E-4D36-B9DD-CD04578C5607}"/>
+                <a16:creationId xmlns:a16="http://schemas.microsoft.com/office/drawing/2014/main" id="{A4E8D43F-C981-4C43-B5C7-09AF248C6AB9}"/>
               </a:ext>
             </a:extLst>
           </p:cNvPr>
@@ -7158,7 +7158,7 @@
           <p:cNvPr id="2" name="">
             <a:extLst xmlns:a="http://schemas.openxmlformats.org/drawingml/2006/main">
               <a:ext uri="{FF2B5EF4-FFF2-40B4-BE49-F238E27FC236}">
-                <a16:creationId xmlns:a16="http://schemas.microsoft.com/office/drawing/2014/main" id="{FF788D82-1E4D-40A7-B497-CBC577777FA0}"/>
+                <a16:creationId xmlns:a16="http://schemas.microsoft.com/office/drawing/2014/main" id="{EA268136-2160-4169-87F2-DE1BF88C9401}"/>
               </a:ext>
             </a:extLst>
           </p:cNvPr>
@@ -7168,7 +7168,7 @@
           <p:nvPr/>
         </p:nvPicPr>
         <p:blipFill>
-          <a:blip xmlns:r="http://schemas.openxmlformats.org/officeDocument/2006/relationships" xmlns:a="http://schemas.openxmlformats.org/drawingml/2006/main" r:embed="Redf461cb222c414a"/>
+          <a:blip xmlns:r="http://schemas.openxmlformats.org/officeDocument/2006/relationships" xmlns:a="http://schemas.openxmlformats.org/drawingml/2006/main" r:embed="R1cc401bc6c9d4a4c"/>
           <a:stretch xmlns:a="http://schemas.openxmlformats.org/drawingml/2006/main"/>
         </p:blipFill>
         <p:spPr>
@@ -7186,7 +7186,7 @@
           <p:cNvPr id="3" name="element-24">
             <a:extLst xmlns:a="http://schemas.openxmlformats.org/drawingml/2006/main">
               <a:ext uri="{FF2B5EF4-FFF2-40B4-BE49-F238E27FC236}">
-                <a16:creationId xmlns:a16="http://schemas.microsoft.com/office/drawing/2014/main" id="{638831E7-AA79-4340-9961-27660E29B068}"/>
+                <a16:creationId xmlns:a16="http://schemas.microsoft.com/office/drawing/2014/main" id="{82914CC1-C920-4B23-9859-1FF1B76A43C7}"/>
               </a:ext>
             </a:extLst>
           </p:cNvPr>
@@ -7345,7 +7345,7 @@
           <p:cNvPr id="4" name="element-25">
             <a:extLst xmlns:a="http://schemas.openxmlformats.org/drawingml/2006/main">
               <a:ext uri="{FF2B5EF4-FFF2-40B4-BE49-F238E27FC236}">
-                <a16:creationId xmlns:a16="http://schemas.microsoft.com/office/drawing/2014/main" id="{0D8A67B8-0A69-4F59-805F-1D0AFB84C4A2}"/>
+                <a16:creationId xmlns:a16="http://schemas.microsoft.com/office/drawing/2014/main" id="{58C19D0D-636B-4112-97F1-B18715D351DC}"/>
               </a:ext>
             </a:extLst>
           </p:cNvPr>
@@ -7504,7 +7504,7 @@
           <p:cNvPr id="5" name="element-26">
             <a:extLst xmlns:a="http://schemas.openxmlformats.org/drawingml/2006/main">
               <a:ext uri="{FF2B5EF4-FFF2-40B4-BE49-F238E27FC236}">
-                <a16:creationId xmlns:a16="http://schemas.microsoft.com/office/drawing/2014/main" id="{10343077-7702-4BFD-8224-191015858085}"/>
+                <a16:creationId xmlns:a16="http://schemas.microsoft.com/office/drawing/2014/main" id="{2E8D402A-698B-47D3-AA75-EDA5E7B15657}"/>
               </a:ext>
             </a:extLst>
           </p:cNvPr>
@@ -7663,7 +7663,7 @@
           <p:cNvPr id="6" name="element-27">
             <a:extLst xmlns:a="http://schemas.openxmlformats.org/drawingml/2006/main">
               <a:ext uri="{FF2B5EF4-FFF2-40B4-BE49-F238E27FC236}">
-                <a16:creationId xmlns:a16="http://schemas.microsoft.com/office/drawing/2014/main" id="{7C7634F3-EB9D-4897-97B0-24B31928D20B}"/>
+                <a16:creationId xmlns:a16="http://schemas.microsoft.com/office/drawing/2014/main" id="{68734CB1-EB5C-4E9B-80F0-4877159EBCB4}"/>
               </a:ext>
             </a:extLst>
           </p:cNvPr>
@@ -7822,7 +7822,7 @@
           <p:cNvPr id="7" name="element-28">
             <a:extLst xmlns:a="http://schemas.openxmlformats.org/drawingml/2006/main">
               <a:ext uri="{FF2B5EF4-FFF2-40B4-BE49-F238E27FC236}">
-                <a16:creationId xmlns:a16="http://schemas.microsoft.com/office/drawing/2014/main" id="{10631869-261B-40B9-8A87-7CCC6BB79385}"/>
+                <a16:creationId xmlns:a16="http://schemas.microsoft.com/office/drawing/2014/main" id="{C058713C-DE22-40C4-A452-63B39504BC37}"/>
               </a:ext>
             </a:extLst>
           </p:cNvPr>
@@ -7981,7 +7981,7 @@
           <p:cNvPr id="8" name="element-29">
             <a:extLst xmlns:a="http://schemas.openxmlformats.org/drawingml/2006/main">
               <a:ext uri="{FF2B5EF4-FFF2-40B4-BE49-F238E27FC236}">
-                <a16:creationId xmlns:a16="http://schemas.microsoft.com/office/drawing/2014/main" id="{CBD3BE5B-97DE-4F78-A35D-6B23E0312310}"/>
+                <a16:creationId xmlns:a16="http://schemas.microsoft.com/office/drawing/2014/main" id="{6C795CE6-6C80-45D5-9EB7-33410941C47F}"/>
               </a:ext>
             </a:extLst>
           </p:cNvPr>
@@ -8140,7 +8140,7 @@
           <p:cNvPr id="9" name="element-30">
             <a:extLst xmlns:a="http://schemas.openxmlformats.org/drawingml/2006/main">
               <a:ext uri="{FF2B5EF4-FFF2-40B4-BE49-F238E27FC236}">
-                <a16:creationId xmlns:a16="http://schemas.microsoft.com/office/drawing/2014/main" id="{47268FAC-1FEE-4D82-BE01-DF7991620844}"/>
+                <a16:creationId xmlns:a16="http://schemas.microsoft.com/office/drawing/2014/main" id="{DC5C4DDD-F095-4DDE-8C5E-EE58785F468E}"/>
               </a:ext>
             </a:extLst>
           </p:cNvPr>
@@ -8299,7 +8299,7 @@
           <p:cNvPr id="10" name="element-31">
             <a:extLst xmlns:a="http://schemas.openxmlformats.org/drawingml/2006/main">
               <a:ext uri="{FF2B5EF4-FFF2-40B4-BE49-F238E27FC236}">
-                <a16:creationId xmlns:a16="http://schemas.microsoft.com/office/drawing/2014/main" id="{88D7787D-5107-4352-9430-895D63D432E1}"/>
+                <a16:creationId xmlns:a16="http://schemas.microsoft.com/office/drawing/2014/main" id="{6DA84866-EEEA-4020-A0C3-7ACB47FE33C2}"/>
               </a:ext>
             </a:extLst>
           </p:cNvPr>
@@ -8458,7 +8458,7 @@
           <p:cNvPr id="11" name="element-32">
             <a:extLst xmlns:a="http://schemas.openxmlformats.org/drawingml/2006/main">
               <a:ext uri="{FF2B5EF4-FFF2-40B4-BE49-F238E27FC236}">
-                <a16:creationId xmlns:a16="http://schemas.microsoft.com/office/drawing/2014/main" id="{F0B074FD-8F37-43FE-B368-3D4663DB4EBB}"/>
+                <a16:creationId xmlns:a16="http://schemas.microsoft.com/office/drawing/2014/main" id="{C7EA82C7-A08F-4594-A6C2-7586C9F0384A}"/>
               </a:ext>
             </a:extLst>
           </p:cNvPr>
@@ -8617,7 +8617,7 @@
           <p:cNvPr id="12" name="element-33">
             <a:extLst xmlns:a="http://schemas.openxmlformats.org/drawingml/2006/main">
               <a:ext uri="{FF2B5EF4-FFF2-40B4-BE49-F238E27FC236}">
-                <a16:creationId xmlns:a16="http://schemas.microsoft.com/office/drawing/2014/main" id="{6DAC00F3-5D64-479A-90EB-0F7F1614B7FD}"/>
+                <a16:creationId xmlns:a16="http://schemas.microsoft.com/office/drawing/2014/main" id="{9AAC060F-0EF8-44C0-BF2D-0046E919F56C}"/>
               </a:ext>
             </a:extLst>
           </p:cNvPr>
@@ -8648,7 +8648,7 @@
           <p:cNvPr id="13" name="element-34">
             <a:extLst xmlns:a="http://schemas.openxmlformats.org/drawingml/2006/main">
               <a:ext uri="{FF2B5EF4-FFF2-40B4-BE49-F238E27FC236}">
-                <a16:creationId xmlns:a16="http://schemas.microsoft.com/office/drawing/2014/main" id="{DB10685F-85A7-4234-BB2F-B3FDEB20EC15}"/>
+                <a16:creationId xmlns:a16="http://schemas.microsoft.com/office/drawing/2014/main" id="{36C6123F-BBD4-437D-9CCD-E9024777B091}"/>
               </a:ext>
             </a:extLst>
           </p:cNvPr>
@@ -8807,7 +8807,7 @@
           <p:cNvPr id="14" name="element-35">
             <a:extLst xmlns:a="http://schemas.openxmlformats.org/drawingml/2006/main">
               <a:ext uri="{FF2B5EF4-FFF2-40B4-BE49-F238E27FC236}">
-                <a16:creationId xmlns:a16="http://schemas.microsoft.com/office/drawing/2014/main" id="{82307CEF-66CF-4F29-AF20-59E860C376D0}"/>
+                <a16:creationId xmlns:a16="http://schemas.microsoft.com/office/drawing/2014/main" id="{405A5FC6-2B13-4560-9F96-0CBC57718845}"/>
               </a:ext>
             </a:extLst>
           </p:cNvPr>
@@ -8964,7 +8964,7 @@
     </p:spTree>
     <p:extLst>
       <p:ext uri="{BB962C8B-B14F-4D97-AF65-F5344CB8AC3E}">
-        <p14:creationId xmlns:p14="http://schemas.microsoft.com/office/powerpoint/2010/main" val="1165804383"/>
+        <p14:creationId xmlns:p14="http://schemas.microsoft.com/office/powerpoint/2010/main" val="200043761"/>
       </p:ext>
     </p:extLst>
   </p:cSld>
@@ -8995,7 +8995,7 @@
           <p:cNvPr id="22" name="element-36">
             <a:extLst xmlns:a="http://schemas.openxmlformats.org/drawingml/2006/main">
               <a:ext uri="{FF2B5EF4-FFF2-40B4-BE49-F238E27FC236}">
-                <a16:creationId xmlns:a16="http://schemas.microsoft.com/office/drawing/2014/main" id="{073DD769-354E-492A-8CFF-993C37EF4E09}"/>
+                <a16:creationId xmlns:a16="http://schemas.microsoft.com/office/drawing/2014/main" id="{7884DA2C-B6CD-4917-AE73-DC3970BAF78D}"/>
               </a:ext>
             </a:extLst>
           </p:cNvPr>
@@ -9177,7 +9177,7 @@
           <p:cNvPr id="2" name="element-37">
             <a:extLst xmlns:a="http://schemas.openxmlformats.org/drawingml/2006/main">
               <a:ext uri="{FF2B5EF4-FFF2-40B4-BE49-F238E27FC236}">
-                <a16:creationId xmlns:a16="http://schemas.microsoft.com/office/drawing/2014/main" id="{3F7E36D7-0A09-4D60-825C-D91E966797C0}"/>
+                <a16:creationId xmlns:a16="http://schemas.microsoft.com/office/drawing/2014/main" id="{F3B155AF-04D4-4A64-BE0C-D0C615415FFC}"/>
               </a:ext>
             </a:extLst>
           </p:cNvPr>
@@ -9210,7 +9210,7 @@
           <p:cNvPr id="3" name="element-38">
             <a:extLst xmlns:a="http://schemas.openxmlformats.org/drawingml/2006/main">
               <a:ext uri="{FF2B5EF4-FFF2-40B4-BE49-F238E27FC236}">
-                <a16:creationId xmlns:a16="http://schemas.microsoft.com/office/drawing/2014/main" id="{96254234-8A57-4215-8352-E62CAE511588}"/>
+                <a16:creationId xmlns:a16="http://schemas.microsoft.com/office/drawing/2014/main" id="{87970F04-9635-4426-BC9C-5C79FE414914}"/>
               </a:ext>
             </a:extLst>
           </p:cNvPr>
@@ -9369,7 +9369,7 @@
           <p:cNvPr id="4" name="element-39">
             <a:extLst xmlns:a="http://schemas.openxmlformats.org/drawingml/2006/main">
               <a:ext uri="{FF2B5EF4-FFF2-40B4-BE49-F238E27FC236}">
-                <a16:creationId xmlns:a16="http://schemas.microsoft.com/office/drawing/2014/main" id="{9E2C9D0F-5760-4E4D-BB51-EC636751D5A7}"/>
+                <a16:creationId xmlns:a16="http://schemas.microsoft.com/office/drawing/2014/main" id="{4148CD30-2398-4B4B-9C69-88D8D01CD802}"/>
               </a:ext>
             </a:extLst>
           </p:cNvPr>
@@ -9528,7 +9528,7 @@
           <p:cNvPr id="5" name="element-40">
             <a:extLst xmlns:a="http://schemas.openxmlformats.org/drawingml/2006/main">
               <a:ext uri="{FF2B5EF4-FFF2-40B4-BE49-F238E27FC236}">
-                <a16:creationId xmlns:a16="http://schemas.microsoft.com/office/drawing/2014/main" id="{74B5503C-10B3-4587-9C4F-EA424A1AC030}"/>
+                <a16:creationId xmlns:a16="http://schemas.microsoft.com/office/drawing/2014/main" id="{69712E4B-C044-478F-91D1-282CA6E09920}"/>
               </a:ext>
             </a:extLst>
           </p:cNvPr>
@@ -9561,7 +9561,7 @@
           <p:cNvPr id="6" name="element-41">
             <a:extLst xmlns:a="http://schemas.openxmlformats.org/drawingml/2006/main">
               <a:ext uri="{FF2B5EF4-FFF2-40B4-BE49-F238E27FC236}">
-                <a16:creationId xmlns:a16="http://schemas.microsoft.com/office/drawing/2014/main" id="{A6D4A592-DF12-4C87-8F90-BAD9CD1BFCB1}"/>
+                <a16:creationId xmlns:a16="http://schemas.microsoft.com/office/drawing/2014/main" id="{F83592E7-891D-4D22-ABD1-1B104185CB63}"/>
               </a:ext>
             </a:extLst>
           </p:cNvPr>
@@ -9720,7 +9720,7 @@
           <p:cNvPr id="7" name="element-42">
             <a:extLst xmlns:a="http://schemas.openxmlformats.org/drawingml/2006/main">
               <a:ext uri="{FF2B5EF4-FFF2-40B4-BE49-F238E27FC236}">
-                <a16:creationId xmlns:a16="http://schemas.microsoft.com/office/drawing/2014/main" id="{38C1A3DF-809D-4A60-A9ED-C981BE4592EB}"/>
+                <a16:creationId xmlns:a16="http://schemas.microsoft.com/office/drawing/2014/main" id="{B643AFA0-E8A4-4823-8C92-7D1FCFB2498F}"/>
               </a:ext>
             </a:extLst>
           </p:cNvPr>
@@ -9879,7 +9879,7 @@
           <p:cNvPr id="8" name="element-43">
             <a:extLst xmlns:a="http://schemas.openxmlformats.org/drawingml/2006/main">
               <a:ext uri="{FF2B5EF4-FFF2-40B4-BE49-F238E27FC236}">
-                <a16:creationId xmlns:a16="http://schemas.microsoft.com/office/drawing/2014/main" id="{ABA5A114-34C0-4551-BA06-AEA9A99B1666}"/>
+                <a16:creationId xmlns:a16="http://schemas.microsoft.com/office/drawing/2014/main" id="{2A6E235F-E0CD-4123-A4D2-105A935035C9}"/>
               </a:ext>
             </a:extLst>
           </p:cNvPr>
@@ -9912,7 +9912,7 @@
           <p:cNvPr id="9" name="element-44">
             <a:extLst xmlns:a="http://schemas.openxmlformats.org/drawingml/2006/main">
               <a:ext uri="{FF2B5EF4-FFF2-40B4-BE49-F238E27FC236}">
-                <a16:creationId xmlns:a16="http://schemas.microsoft.com/office/drawing/2014/main" id="{8921FC67-B313-4EAE-816E-89C645CF5E4F}"/>
+                <a16:creationId xmlns:a16="http://schemas.microsoft.com/office/drawing/2014/main" id="{CC481556-DD79-4454-A3B0-6BE7BE0D48CA}"/>
               </a:ext>
             </a:extLst>
           </p:cNvPr>
@@ -10071,7 +10071,7 @@
           <p:cNvPr id="10" name="element-45">
             <a:extLst xmlns:a="http://schemas.openxmlformats.org/drawingml/2006/main">
               <a:ext uri="{FF2B5EF4-FFF2-40B4-BE49-F238E27FC236}">
-                <a16:creationId xmlns:a16="http://schemas.microsoft.com/office/drawing/2014/main" id="{3780F99B-5F2D-49FB-9EA9-C7EDA4E8DACE}"/>
+                <a16:creationId xmlns:a16="http://schemas.microsoft.com/office/drawing/2014/main" id="{D0AD7CDB-D3A2-4E70-BFD7-5EAFE365E1F0}"/>
               </a:ext>
             </a:extLst>
           </p:cNvPr>
@@ -10230,7 +10230,7 @@
           <p:cNvPr id="11" name="element-46">
             <a:extLst xmlns:a="http://schemas.openxmlformats.org/drawingml/2006/main">
               <a:ext uri="{FF2B5EF4-FFF2-40B4-BE49-F238E27FC236}">
-                <a16:creationId xmlns:a16="http://schemas.microsoft.com/office/drawing/2014/main" id="{7E19495C-52A4-4013-B770-4674724E0B17}"/>
+                <a16:creationId xmlns:a16="http://schemas.microsoft.com/office/drawing/2014/main" id="{AD000BB6-9182-4C88-8CED-03DED421D359}"/>
               </a:ext>
             </a:extLst>
           </p:cNvPr>
@@ -10263,7 +10263,7 @@
           <p:cNvPr id="12" name="element-47">
             <a:extLst xmlns:a="http://schemas.openxmlformats.org/drawingml/2006/main">
               <a:ext uri="{FF2B5EF4-FFF2-40B4-BE49-F238E27FC236}">
-                <a16:creationId xmlns:a16="http://schemas.microsoft.com/office/drawing/2014/main" id="{DB1A74EE-6DCC-4CB9-A4F7-D92E99BDCB48}"/>
+                <a16:creationId xmlns:a16="http://schemas.microsoft.com/office/drawing/2014/main" id="{0E2C5FF6-9D7E-4C75-956D-2A7627E0640E}"/>
               </a:ext>
             </a:extLst>
           </p:cNvPr>
@@ -10422,7 +10422,7 @@
           <p:cNvPr id="13" name="element-48">
             <a:extLst xmlns:a="http://schemas.openxmlformats.org/drawingml/2006/main">
               <a:ext uri="{FF2B5EF4-FFF2-40B4-BE49-F238E27FC236}">
-                <a16:creationId xmlns:a16="http://schemas.microsoft.com/office/drawing/2014/main" id="{EA298D78-5435-449E-88AA-A164F7E9198F}"/>
+                <a16:creationId xmlns:a16="http://schemas.microsoft.com/office/drawing/2014/main" id="{97453918-BCD9-45F0-B9D6-1BA4261E90D2}"/>
               </a:ext>
             </a:extLst>
           </p:cNvPr>
@@ -10581,7 +10581,7 @@
           <p:cNvPr id="14" name="element-49">
             <a:extLst xmlns:a="http://schemas.openxmlformats.org/drawingml/2006/main">
               <a:ext uri="{FF2B5EF4-FFF2-40B4-BE49-F238E27FC236}">
-                <a16:creationId xmlns:a16="http://schemas.microsoft.com/office/drawing/2014/main" id="{2EB7B145-F437-4C20-812A-EEFC14F9C2AA}"/>
+                <a16:creationId xmlns:a16="http://schemas.microsoft.com/office/drawing/2014/main" id="{5B0239C2-E60D-4459-A2F6-CCE3978E657A}"/>
               </a:ext>
             </a:extLst>
           </p:cNvPr>
@@ -10740,7 +10740,7 @@
           <p:cNvPr id="15" name="element-50">
             <a:extLst xmlns:a="http://schemas.openxmlformats.org/drawingml/2006/main">
               <a:ext uri="{FF2B5EF4-FFF2-40B4-BE49-F238E27FC236}">
-                <a16:creationId xmlns:a16="http://schemas.microsoft.com/office/drawing/2014/main" id="{D0E73B1F-AA59-4FD5-B22B-384C659DE0D5}"/>
+                <a16:creationId xmlns:a16="http://schemas.microsoft.com/office/drawing/2014/main" id="{171ABEFE-FA71-4D17-A395-AC724ED6BF63}"/>
               </a:ext>
             </a:extLst>
           </p:cNvPr>
@@ -10899,7 +10899,7 @@
           <p:cNvPr id="16" name="element-51">
             <a:extLst xmlns:a="http://schemas.openxmlformats.org/drawingml/2006/main">
               <a:ext uri="{FF2B5EF4-FFF2-40B4-BE49-F238E27FC236}">
-                <a16:creationId xmlns:a16="http://schemas.microsoft.com/office/drawing/2014/main" id="{2F33EB39-3B4D-4352-B5D4-D1E380FC7E64}"/>
+                <a16:creationId xmlns:a16="http://schemas.microsoft.com/office/drawing/2014/main" id="{1BB10F08-654E-4291-9E32-78CD20597EDE}"/>
               </a:ext>
             </a:extLst>
           </p:cNvPr>
@@ -11104,7 +11104,7 @@
           <p:cNvPr id="17" name="element-52">
             <a:extLst xmlns:a="http://schemas.openxmlformats.org/drawingml/2006/main">
               <a:ext uri="{FF2B5EF4-FFF2-40B4-BE49-F238E27FC236}">
-                <a16:creationId xmlns:a16="http://schemas.microsoft.com/office/drawing/2014/main" id="{99CD5716-F267-4982-89C8-D5D073B0C6C6}"/>
+                <a16:creationId xmlns:a16="http://schemas.microsoft.com/office/drawing/2014/main" id="{1A338C7F-3CA9-4232-BB95-97F0A8077530}"/>
               </a:ext>
             </a:extLst>
           </p:cNvPr>
@@ -11263,7 +11263,7 @@
           <p:cNvPr id="18" name="element-53">
             <a:extLst xmlns:a="http://schemas.openxmlformats.org/drawingml/2006/main">
               <a:ext uri="{FF2B5EF4-FFF2-40B4-BE49-F238E27FC236}">
-                <a16:creationId xmlns:a16="http://schemas.microsoft.com/office/drawing/2014/main" id="{7D0B693B-A86C-4466-B09F-4F57424D4B0E}"/>
+                <a16:creationId xmlns:a16="http://schemas.microsoft.com/office/drawing/2014/main" id="{8BDD72A3-00C4-439D-8622-C29ADDC9F8BE}"/>
               </a:ext>
             </a:extLst>
           </p:cNvPr>
@@ -11422,7 +11422,7 @@
           <p:cNvPr id="19" name="element-54">
             <a:extLst xmlns:a="http://schemas.openxmlformats.org/drawingml/2006/main">
               <a:ext uri="{FF2B5EF4-FFF2-40B4-BE49-F238E27FC236}">
-                <a16:creationId xmlns:a16="http://schemas.microsoft.com/office/drawing/2014/main" id="{7C3CACD3-59D6-4D31-AE01-002EDADEA575}"/>
+                <a16:creationId xmlns:a16="http://schemas.microsoft.com/office/drawing/2014/main" id="{5EB25EB5-950C-433C-98B8-BC00426C2DDE}"/>
               </a:ext>
             </a:extLst>
           </p:cNvPr>
@@ -11581,7 +11581,7 @@
           <p:cNvPr id="20" name="element-55">
             <a:extLst xmlns:a="http://schemas.openxmlformats.org/drawingml/2006/main">
               <a:ext uri="{FF2B5EF4-FFF2-40B4-BE49-F238E27FC236}">
-                <a16:creationId xmlns:a16="http://schemas.microsoft.com/office/drawing/2014/main" id="{8BA1CBF0-6B14-4DBF-9DCC-DB0564F66829}"/>
+                <a16:creationId xmlns:a16="http://schemas.microsoft.com/office/drawing/2014/main" id="{B247793C-8EDB-4C19-920D-8DD0824F55BE}"/>
               </a:ext>
             </a:extLst>
           </p:cNvPr>
@@ -11730,7 +11730,7 @@
                 <a:ea typeface="TeX Gyre Adventor"/>
                 <a:cs typeface="TeX Gyre Adventor"/>
               </a:rPr>
-              <a:t>Private notes and photos stay outside TinyFish. Authenticated host save/reopen still needs live verification.</a:t>
+              <a:t>Private notes and photos stay outside TinyFish. Selected facts keep their source link and retrieval time.</a:t>
             </a:r>
           </a:p>
         </p:txBody>
@@ -11740,7 +11740,7 @@
           <p:cNvPr id="21" name="element-56">
             <a:extLst xmlns:a="http://schemas.openxmlformats.org/drawingml/2006/main">
               <a:ext uri="{FF2B5EF4-FFF2-40B4-BE49-F238E27FC236}">
-                <a16:creationId xmlns:a16="http://schemas.microsoft.com/office/drawing/2014/main" id="{0BE53281-3D45-44D9-ABE7-9E1BBD6AAA36}"/>
+                <a16:creationId xmlns:a16="http://schemas.microsoft.com/office/drawing/2014/main" id="{070017F1-775D-4146-A96E-82AB152F9E59}"/>
               </a:ext>
             </a:extLst>
           </p:cNvPr>
@@ -11897,7 +11897,7 @@
     </p:spTree>
     <p:extLst>
       <p:ext uri="{BB962C8B-B14F-4D97-AF65-F5344CB8AC3E}">
-        <p14:creationId xmlns:p14="http://schemas.microsoft.com/office/powerpoint/2010/main" val="1129870425"/>
+        <p14:creationId xmlns:p14="http://schemas.microsoft.com/office/powerpoint/2010/main" val="404788025"/>
       </p:ext>
     </p:extLst>
   </p:cSld>
@@ -11928,7 +11928,7 @@
           <p:cNvPr id="28" name="element-57">
             <a:extLst xmlns:a="http://schemas.openxmlformats.org/drawingml/2006/main">
               <a:ext uri="{FF2B5EF4-FFF2-40B4-BE49-F238E27FC236}">
-                <a16:creationId xmlns:a16="http://schemas.microsoft.com/office/drawing/2014/main" id="{EB12B609-B999-45EC-A184-5EADB96E439E}"/>
+                <a16:creationId xmlns:a16="http://schemas.microsoft.com/office/drawing/2014/main" id="{B4795A6F-D111-457E-90B4-3BE13050E90D}"/>
               </a:ext>
             </a:extLst>
           </p:cNvPr>
@@ -12110,7 +12110,7 @@
           <p:cNvPr id="2" name="element-58">
             <a:extLst xmlns:a="http://schemas.openxmlformats.org/drawingml/2006/main">
               <a:ext uri="{FF2B5EF4-FFF2-40B4-BE49-F238E27FC236}">
-                <a16:creationId xmlns:a16="http://schemas.microsoft.com/office/drawing/2014/main" id="{DDCF38F6-33BD-4021-8F72-C70804C47217}"/>
+                <a16:creationId xmlns:a16="http://schemas.microsoft.com/office/drawing/2014/main" id="{A635D442-C02F-448F-A298-5541BBCCA455}"/>
               </a:ext>
             </a:extLst>
           </p:cNvPr>
@@ -12143,7 +12143,7 @@
           <p:cNvPr id="3" name="element-59">
             <a:extLst xmlns:a="http://schemas.openxmlformats.org/drawingml/2006/main">
               <a:ext uri="{FF2B5EF4-FFF2-40B4-BE49-F238E27FC236}">
-                <a16:creationId xmlns:a16="http://schemas.microsoft.com/office/drawing/2014/main" id="{65B165F6-F3C5-42C8-9591-7125FAE053E2}"/>
+                <a16:creationId xmlns:a16="http://schemas.microsoft.com/office/drawing/2014/main" id="{ECDADCCD-DA38-4ABB-ACC5-6E41A2DD7D68}"/>
               </a:ext>
             </a:extLst>
           </p:cNvPr>
@@ -12302,7 +12302,7 @@
           <p:cNvPr id="4" name="element-60">
             <a:extLst xmlns:a="http://schemas.openxmlformats.org/drawingml/2006/main">
               <a:ext uri="{FF2B5EF4-FFF2-40B4-BE49-F238E27FC236}">
-                <a16:creationId xmlns:a16="http://schemas.microsoft.com/office/drawing/2014/main" id="{9BB82D71-BDE0-4E17-BEDB-2C88A5E96971}"/>
+                <a16:creationId xmlns:a16="http://schemas.microsoft.com/office/drawing/2014/main" id="{F88934BD-4733-4C18-A19A-73AC19D34DD9}"/>
               </a:ext>
             </a:extLst>
           </p:cNvPr>
@@ -12484,7 +12484,7 @@
           <p:cNvPr id="5" name="element-61">
             <a:extLst xmlns:a="http://schemas.openxmlformats.org/drawingml/2006/main">
               <a:ext uri="{FF2B5EF4-FFF2-40B4-BE49-F238E27FC236}">
-                <a16:creationId xmlns:a16="http://schemas.microsoft.com/office/drawing/2014/main" id="{8BF064D1-AE72-464A-8B7B-6CDFB9584AA2}"/>
+                <a16:creationId xmlns:a16="http://schemas.microsoft.com/office/drawing/2014/main" id="{17EDC7D2-B988-47E6-96A5-59CEE79C271B}"/>
               </a:ext>
             </a:extLst>
           </p:cNvPr>
@@ -12517,7 +12517,7 @@
           <p:cNvPr id="6" name="element-62">
             <a:extLst xmlns:a="http://schemas.openxmlformats.org/drawingml/2006/main">
               <a:ext uri="{FF2B5EF4-FFF2-40B4-BE49-F238E27FC236}">
-                <a16:creationId xmlns:a16="http://schemas.microsoft.com/office/drawing/2014/main" id="{266E3774-EA77-45C3-9102-C4EB61EB8086}"/>
+                <a16:creationId xmlns:a16="http://schemas.microsoft.com/office/drawing/2014/main" id="{A7F0EAFB-C86F-4778-9DB8-01678BF78721}"/>
               </a:ext>
             </a:extLst>
           </p:cNvPr>
@@ -12676,7 +12676,7 @@
           <p:cNvPr id="7" name="element-63">
             <a:extLst xmlns:a="http://schemas.openxmlformats.org/drawingml/2006/main">
               <a:ext uri="{FF2B5EF4-FFF2-40B4-BE49-F238E27FC236}">
-                <a16:creationId xmlns:a16="http://schemas.microsoft.com/office/drawing/2014/main" id="{BA6CA855-206E-4218-98FA-F1F87206D77F}"/>
+                <a16:creationId xmlns:a16="http://schemas.microsoft.com/office/drawing/2014/main" id="{A36CEDD7-66D1-4F44-A391-03F07C729A80}"/>
               </a:ext>
             </a:extLst>
           </p:cNvPr>
@@ -12858,7 +12858,7 @@
           <p:cNvPr id="8" name="element-64">
             <a:extLst xmlns:a="http://schemas.openxmlformats.org/drawingml/2006/main">
               <a:ext uri="{FF2B5EF4-FFF2-40B4-BE49-F238E27FC236}">
-                <a16:creationId xmlns:a16="http://schemas.microsoft.com/office/drawing/2014/main" id="{A799F22C-AE9B-4561-94C2-1F2BB43FCDA8}"/>
+                <a16:creationId xmlns:a16="http://schemas.microsoft.com/office/drawing/2014/main" id="{27F0A34B-671B-4018-B79E-9711DF805FE6}"/>
               </a:ext>
             </a:extLst>
           </p:cNvPr>
@@ -12891,7 +12891,7 @@
           <p:cNvPr id="9" name="element-65">
             <a:extLst xmlns:a="http://schemas.openxmlformats.org/drawingml/2006/main">
               <a:ext uri="{FF2B5EF4-FFF2-40B4-BE49-F238E27FC236}">
-                <a16:creationId xmlns:a16="http://schemas.microsoft.com/office/drawing/2014/main" id="{110CBA4C-C787-4F3E-AA8A-0CD44580C805}"/>
+                <a16:creationId xmlns:a16="http://schemas.microsoft.com/office/drawing/2014/main" id="{21624169-0FE7-4D32-9B7E-7D4D83BEC3EA}"/>
               </a:ext>
             </a:extLst>
           </p:cNvPr>
@@ -13050,7 +13050,7 @@
           <p:cNvPr id="10" name="element-66">
             <a:extLst xmlns:a="http://schemas.openxmlformats.org/drawingml/2006/main">
               <a:ext uri="{FF2B5EF4-FFF2-40B4-BE49-F238E27FC236}">
-                <a16:creationId xmlns:a16="http://schemas.microsoft.com/office/drawing/2014/main" id="{09F19A43-8333-4EF8-92B5-47B5AA0023C8}"/>
+                <a16:creationId xmlns:a16="http://schemas.microsoft.com/office/drawing/2014/main" id="{06714F8D-635B-4A58-911A-1A474032B656}"/>
               </a:ext>
             </a:extLst>
           </p:cNvPr>
@@ -13232,7 +13232,7 @@
           <p:cNvPr id="11" name="element-67">
             <a:extLst xmlns:a="http://schemas.openxmlformats.org/drawingml/2006/main">
               <a:ext uri="{FF2B5EF4-FFF2-40B4-BE49-F238E27FC236}">
-                <a16:creationId xmlns:a16="http://schemas.microsoft.com/office/drawing/2014/main" id="{8500984E-442B-4349-9819-9CF2C1C26127}"/>
+                <a16:creationId xmlns:a16="http://schemas.microsoft.com/office/drawing/2014/main" id="{4A6BCF33-82ED-4575-8151-132E07135B5D}"/>
               </a:ext>
             </a:extLst>
           </p:cNvPr>
@@ -13265,7 +13265,7 @@
           <p:cNvPr id="12" name="element-68">
             <a:extLst xmlns:a="http://schemas.openxmlformats.org/drawingml/2006/main">
               <a:ext uri="{FF2B5EF4-FFF2-40B4-BE49-F238E27FC236}">
-                <a16:creationId xmlns:a16="http://schemas.microsoft.com/office/drawing/2014/main" id="{7EB0590C-E09B-49C2-A6F0-6785DD27ED7C}"/>
+                <a16:creationId xmlns:a16="http://schemas.microsoft.com/office/drawing/2014/main" id="{1B4203A5-BD8B-448B-83A2-D5411174D6EE}"/>
               </a:ext>
             </a:extLst>
           </p:cNvPr>
@@ -13424,7 +13424,7 @@
           <p:cNvPr id="13" name="element-69">
             <a:extLst xmlns:a="http://schemas.openxmlformats.org/drawingml/2006/main">
               <a:ext uri="{FF2B5EF4-FFF2-40B4-BE49-F238E27FC236}">
-                <a16:creationId xmlns:a16="http://schemas.microsoft.com/office/drawing/2014/main" id="{6FCBF9EC-57D1-463A-BD39-CA681B28FCB7}"/>
+                <a16:creationId xmlns:a16="http://schemas.microsoft.com/office/drawing/2014/main" id="{42CC788E-E370-4126-9E0E-A1A5E2DD4B7C}"/>
               </a:ext>
             </a:extLst>
           </p:cNvPr>
@@ -13606,7 +13606,7 @@
           <p:cNvPr id="14" name="element-70">
             <a:extLst xmlns:a="http://schemas.openxmlformats.org/drawingml/2006/main">
               <a:ext uri="{FF2B5EF4-FFF2-40B4-BE49-F238E27FC236}">
-                <a16:creationId xmlns:a16="http://schemas.microsoft.com/office/drawing/2014/main" id="{190B17ED-71BE-4681-9525-576F0E87E5AF}"/>
+                <a16:creationId xmlns:a16="http://schemas.microsoft.com/office/drawing/2014/main" id="{56E2277C-E405-4E15-AB6B-BBE63CC1764F}"/>
               </a:ext>
             </a:extLst>
           </p:cNvPr>
@@ -13639,7 +13639,7 @@
           <p:cNvPr id="15" name="element-71">
             <a:extLst xmlns:a="http://schemas.openxmlformats.org/drawingml/2006/main">
               <a:ext uri="{FF2B5EF4-FFF2-40B4-BE49-F238E27FC236}">
-                <a16:creationId xmlns:a16="http://schemas.microsoft.com/office/drawing/2014/main" id="{5DFA4C09-CFDB-43D9-B540-D5C95A18993D}"/>
+                <a16:creationId xmlns:a16="http://schemas.microsoft.com/office/drawing/2014/main" id="{F78D7257-A9F3-4120-A75E-8EE8C364D314}"/>
               </a:ext>
             </a:extLst>
           </p:cNvPr>
@@ -13798,7 +13798,7 @@
           <p:cNvPr id="16" name="element-72">
             <a:extLst xmlns:a="http://schemas.openxmlformats.org/drawingml/2006/main">
               <a:ext uri="{FF2B5EF4-FFF2-40B4-BE49-F238E27FC236}">
-                <a16:creationId xmlns:a16="http://schemas.microsoft.com/office/drawing/2014/main" id="{3E468614-4EA8-4D73-9A41-BCCF4C2697B4}"/>
+                <a16:creationId xmlns:a16="http://schemas.microsoft.com/office/drawing/2014/main" id="{AA8EE365-1411-49DD-8AA5-11B5FE4EEA46}"/>
               </a:ext>
             </a:extLst>
           </p:cNvPr>
@@ -13980,7 +13980,7 @@
           <p:cNvPr id="17" name="element-73">
             <a:extLst xmlns:a="http://schemas.openxmlformats.org/drawingml/2006/main">
               <a:ext uri="{FF2B5EF4-FFF2-40B4-BE49-F238E27FC236}">
-                <a16:creationId xmlns:a16="http://schemas.microsoft.com/office/drawing/2014/main" id="{77B82488-888D-4DBF-9458-C6B577A2FC5E}"/>
+                <a16:creationId xmlns:a16="http://schemas.microsoft.com/office/drawing/2014/main" id="{EA3DB8FC-ECD9-46F4-BF91-0C8EB1E1BF59}"/>
               </a:ext>
             </a:extLst>
           </p:cNvPr>
@@ -14013,7 +14013,7 @@
           <p:cNvPr id="18" name="element-74">
             <a:extLst xmlns:a="http://schemas.openxmlformats.org/drawingml/2006/main">
               <a:ext uri="{FF2B5EF4-FFF2-40B4-BE49-F238E27FC236}">
-                <a16:creationId xmlns:a16="http://schemas.microsoft.com/office/drawing/2014/main" id="{577FACFA-4AFD-4B27-ACC2-05FE33160986}"/>
+                <a16:creationId xmlns:a16="http://schemas.microsoft.com/office/drawing/2014/main" id="{47D14BB5-6CBF-4D82-B277-E577E7E414A8}"/>
               </a:ext>
             </a:extLst>
           </p:cNvPr>
@@ -14172,7 +14172,7 @@
           <p:cNvPr id="19" name="element-75">
             <a:extLst xmlns:a="http://schemas.openxmlformats.org/drawingml/2006/main">
               <a:ext uri="{FF2B5EF4-FFF2-40B4-BE49-F238E27FC236}">
-                <a16:creationId xmlns:a16="http://schemas.microsoft.com/office/drawing/2014/main" id="{4C07A537-C77D-47B2-B3C3-D48F3BC3C6F2}"/>
+                <a16:creationId xmlns:a16="http://schemas.microsoft.com/office/drawing/2014/main" id="{EE18E2AD-D8D3-4618-B738-8EC56D2132DF}"/>
               </a:ext>
             </a:extLst>
           </p:cNvPr>
@@ -14354,7 +14354,7 @@
           <p:cNvPr id="20" name="element-76">
             <a:extLst xmlns:a="http://schemas.openxmlformats.org/drawingml/2006/main">
               <a:ext uri="{FF2B5EF4-FFF2-40B4-BE49-F238E27FC236}">
-                <a16:creationId xmlns:a16="http://schemas.microsoft.com/office/drawing/2014/main" id="{FBFB42FC-A786-48B6-84E1-8D95B1BA97B7}"/>
+                <a16:creationId xmlns:a16="http://schemas.microsoft.com/office/drawing/2014/main" id="{7BFF1873-D906-4753-AF79-F6236730D7E8}"/>
               </a:ext>
             </a:extLst>
           </p:cNvPr>
@@ -14385,7 +14385,7 @@
           <p:cNvPr id="21" name="element-77">
             <a:extLst xmlns:a="http://schemas.openxmlformats.org/drawingml/2006/main">
               <a:ext uri="{FF2B5EF4-FFF2-40B4-BE49-F238E27FC236}">
-                <a16:creationId xmlns:a16="http://schemas.microsoft.com/office/drawing/2014/main" id="{D7AC5C92-9EBE-4209-B1DC-A27D233AF3C7}"/>
+                <a16:creationId xmlns:a16="http://schemas.microsoft.com/office/drawing/2014/main" id="{9F88FB8A-4EF8-4A6B-82B0-68B26A239D2A}"/>
               </a:ext>
             </a:extLst>
           </p:cNvPr>
@@ -14416,7 +14416,7 @@
           <p:cNvPr id="22" name="element-78">
             <a:extLst xmlns:a="http://schemas.openxmlformats.org/drawingml/2006/main">
               <a:ext uri="{FF2B5EF4-FFF2-40B4-BE49-F238E27FC236}">
-                <a16:creationId xmlns:a16="http://schemas.microsoft.com/office/drawing/2014/main" id="{076A08B1-F4B2-4586-A291-0F814616705D}"/>
+                <a16:creationId xmlns:a16="http://schemas.microsoft.com/office/drawing/2014/main" id="{1FF71538-F96D-466D-AB4C-54095AFB5F77}"/>
               </a:ext>
             </a:extLst>
           </p:cNvPr>
@@ -14447,7 +14447,7 @@
           <p:cNvPr id="23" name="element-79">
             <a:extLst xmlns:a="http://schemas.openxmlformats.org/drawingml/2006/main">
               <a:ext uri="{FF2B5EF4-FFF2-40B4-BE49-F238E27FC236}">
-                <a16:creationId xmlns:a16="http://schemas.microsoft.com/office/drawing/2014/main" id="{6F80DCF7-E4AC-42E6-88B7-2167959AB27F}"/>
+                <a16:creationId xmlns:a16="http://schemas.microsoft.com/office/drawing/2014/main" id="{4C39652E-0E1D-474E-B96A-EAC3B98B06E3}"/>
               </a:ext>
             </a:extLst>
           </p:cNvPr>
@@ -14478,7 +14478,7 @@
           <p:cNvPr id="24" name="element-80">
             <a:extLst xmlns:a="http://schemas.openxmlformats.org/drawingml/2006/main">
               <a:ext uri="{FF2B5EF4-FFF2-40B4-BE49-F238E27FC236}">
-                <a16:creationId xmlns:a16="http://schemas.microsoft.com/office/drawing/2014/main" id="{8ACF66EA-D10E-4F5D-81C7-D351CA3F2207}"/>
+                <a16:creationId xmlns:a16="http://schemas.microsoft.com/office/drawing/2014/main" id="{D77E8302-AA8C-4D3E-97CE-A44425CD2193}"/>
               </a:ext>
             </a:extLst>
           </p:cNvPr>
@@ -14509,7 +14509,7 @@
           <p:cNvPr id="25" name="element-81">
             <a:extLst xmlns:a="http://schemas.openxmlformats.org/drawingml/2006/main">
               <a:ext uri="{FF2B5EF4-FFF2-40B4-BE49-F238E27FC236}">
-                <a16:creationId xmlns:a16="http://schemas.microsoft.com/office/drawing/2014/main" id="{0CA5E236-28E2-4988-9CD3-7FA10DA8FCEC}"/>
+                <a16:creationId xmlns:a16="http://schemas.microsoft.com/office/drawing/2014/main" id="{4DD85197-92EF-4D66-B4CE-440993A2BE6D}"/>
               </a:ext>
             </a:extLst>
           </p:cNvPr>
@@ -14658,7 +14658,7 @@
                 <a:ea typeface="TeX Gyre Adventor"/>
                 <a:cs typeface="TeX Gyre Adventor"/>
               </a:rPr>
-              <a:t>Technical approach: async TinyFish jobs, signed owner-bound run tokens, explicit fact selection, isolated customer hosting.</a:t>
+              <a:t>Technical approach: async TinyFish jobs, signed account tokens, explicit fact selection and private account storage.</a:t>
             </a:r>
           </a:p>
         </p:txBody>
@@ -14668,7 +14668,7 @@
           <p:cNvPr id="26" name="element-82">
             <a:extLst xmlns:a="http://schemas.openxmlformats.org/drawingml/2006/main">
               <a:ext uri="{FF2B5EF4-FFF2-40B4-BE49-F238E27FC236}">
-                <a16:creationId xmlns:a16="http://schemas.microsoft.com/office/drawing/2014/main" id="{F7426FCD-C3F8-4FB9-B5EB-46E0C3EC82A5}"/>
+                <a16:creationId xmlns:a16="http://schemas.microsoft.com/office/drawing/2014/main" id="{5560FD55-2BEA-4F9B-9BE4-FABA9B915439}"/>
               </a:ext>
             </a:extLst>
           </p:cNvPr>
@@ -14827,7 +14827,7 @@
           <p:cNvPr id="27" name="element-83">
             <a:extLst xmlns:a="http://schemas.openxmlformats.org/drawingml/2006/main">
               <a:ext uri="{FF2B5EF4-FFF2-40B4-BE49-F238E27FC236}">
-                <a16:creationId xmlns:a16="http://schemas.microsoft.com/office/drawing/2014/main" id="{63660373-7198-44E2-B780-8D18568D817B}"/>
+                <a16:creationId xmlns:a16="http://schemas.microsoft.com/office/drawing/2014/main" id="{8D5E53C6-E85A-4D12-8458-F1803FCBB140}"/>
               </a:ext>
             </a:extLst>
           </p:cNvPr>
@@ -14984,7 +14984,7 @@
     </p:spTree>
     <p:extLst>
       <p:ext uri="{BB962C8B-B14F-4D97-AF65-F5344CB8AC3E}">
-        <p14:creationId xmlns:p14="http://schemas.microsoft.com/office/powerpoint/2010/main" val="287013422"/>
+        <p14:creationId xmlns:p14="http://schemas.microsoft.com/office/powerpoint/2010/main" val="1897418948"/>
       </p:ext>
     </p:extLst>
   </p:cSld>
@@ -15015,7 +15015,7 @@
           <p:cNvPr id="12" name="element-84">
             <a:extLst xmlns:a="http://schemas.openxmlformats.org/drawingml/2006/main">
               <a:ext uri="{FF2B5EF4-FFF2-40B4-BE49-F238E27FC236}">
-                <a16:creationId xmlns:a16="http://schemas.microsoft.com/office/drawing/2014/main" id="{54E92EB6-B725-42E2-A17A-4F2013C0B2E7}"/>
+                <a16:creationId xmlns:a16="http://schemas.microsoft.com/office/drawing/2014/main" id="{8EA1C601-9577-47E2-8D02-4AFEABC07019}"/>
               </a:ext>
             </a:extLst>
           </p:cNvPr>
@@ -15174,7 +15174,7 @@
           <p:cNvPr id="2" name="element-85">
             <a:extLst xmlns:a="http://schemas.openxmlformats.org/drawingml/2006/main">
               <a:ext uri="{FF2B5EF4-FFF2-40B4-BE49-F238E27FC236}">
-                <a16:creationId xmlns:a16="http://schemas.microsoft.com/office/drawing/2014/main" id="{3A0387E6-A15B-4AB0-BD3B-D2DC1E761809}"/>
+                <a16:creationId xmlns:a16="http://schemas.microsoft.com/office/drawing/2014/main" id="{852FB033-1789-4C7E-917B-FB7897EDC3D5}"/>
               </a:ext>
             </a:extLst>
           </p:cNvPr>
@@ -15333,7 +15333,7 @@
           <p:cNvPr id="3" name="element-86">
             <a:extLst xmlns:a="http://schemas.openxmlformats.org/drawingml/2006/main">
               <a:ext uri="{FF2B5EF4-FFF2-40B4-BE49-F238E27FC236}">
-                <a16:creationId xmlns:a16="http://schemas.microsoft.com/office/drawing/2014/main" id="{E66456EB-C25E-471B-A869-B145C5488EF3}"/>
+                <a16:creationId xmlns:a16="http://schemas.microsoft.com/office/drawing/2014/main" id="{97606ACD-0768-4881-9B56-8B1843002AA1}"/>
               </a:ext>
             </a:extLst>
           </p:cNvPr>
@@ -15492,7 +15492,7 @@
           <p:cNvPr id="4" name="element-87">
             <a:extLst xmlns:a="http://schemas.openxmlformats.org/drawingml/2006/main">
               <a:ext uri="{FF2B5EF4-FFF2-40B4-BE49-F238E27FC236}">
-                <a16:creationId xmlns:a16="http://schemas.microsoft.com/office/drawing/2014/main" id="{53D52722-0162-4D88-856E-5970200FD54D}"/>
+                <a16:creationId xmlns:a16="http://schemas.microsoft.com/office/drawing/2014/main" id="{37436BB6-C91F-4C63-AE2F-015CDCE6D4B3}"/>
               </a:ext>
             </a:extLst>
           </p:cNvPr>
@@ -15651,7 +15651,7 @@
           <p:cNvPr id="5" name="element-88">
             <a:extLst xmlns:a="http://schemas.openxmlformats.org/drawingml/2006/main">
               <a:ext uri="{FF2B5EF4-FFF2-40B4-BE49-F238E27FC236}">
-                <a16:creationId xmlns:a16="http://schemas.microsoft.com/office/drawing/2014/main" id="{F4409079-05BA-40A5-A90B-E22AD33CFA8E}"/>
+                <a16:creationId xmlns:a16="http://schemas.microsoft.com/office/drawing/2014/main" id="{D5F97209-93D0-4811-8B04-E44F6F68512C}"/>
               </a:ext>
             </a:extLst>
           </p:cNvPr>
@@ -15810,7 +15810,7 @@
           <p:cNvPr id="6" name="element-89">
             <a:extLst xmlns:a="http://schemas.openxmlformats.org/drawingml/2006/main">
               <a:ext uri="{FF2B5EF4-FFF2-40B4-BE49-F238E27FC236}">
-                <a16:creationId xmlns:a16="http://schemas.microsoft.com/office/drawing/2014/main" id="{347A8F41-7DB0-4C41-B582-EA6F1F38EC2A}"/>
+                <a16:creationId xmlns:a16="http://schemas.microsoft.com/office/drawing/2014/main" id="{42B030A8-C368-49AA-A44C-72E59D732DF4}"/>
               </a:ext>
             </a:extLst>
           </p:cNvPr>
@@ -15969,7 +15969,7 @@
           <p:cNvPr id="7" name="element-90">
             <a:extLst xmlns:a="http://schemas.openxmlformats.org/drawingml/2006/main">
               <a:ext uri="{FF2B5EF4-FFF2-40B4-BE49-F238E27FC236}">
-                <a16:creationId xmlns:a16="http://schemas.microsoft.com/office/drawing/2014/main" id="{A344D2B7-89D4-4E9D-BF5B-17285ED5402E}"/>
+                <a16:creationId xmlns:a16="http://schemas.microsoft.com/office/drawing/2014/main" id="{B33ADE43-350C-4E77-94B9-AAE995B8378F}"/>
               </a:ext>
             </a:extLst>
           </p:cNvPr>
@@ -16151,7 +16151,7 @@
           <p:cNvPr id="8" name="">
             <a:extLst xmlns:a="http://schemas.openxmlformats.org/drawingml/2006/main">
               <a:ext uri="{FF2B5EF4-FFF2-40B4-BE49-F238E27FC236}">
-                <a16:creationId xmlns:a16="http://schemas.microsoft.com/office/drawing/2014/main" id="{6859B774-DCB6-4F4A-AB7B-4552389C2B0C}"/>
+                <a16:creationId xmlns:a16="http://schemas.microsoft.com/office/drawing/2014/main" id="{9473013E-5FB6-4D8E-9B4E-31D3D7ACCADA}"/>
               </a:ext>
             </a:extLst>
           </p:cNvPr>
@@ -16912,7 +16912,7 @@
           <p:cNvPr id="9" name="element-91">
             <a:extLst xmlns:a="http://schemas.openxmlformats.org/drawingml/2006/main">
               <a:ext uri="{FF2B5EF4-FFF2-40B4-BE49-F238E27FC236}">
-                <a16:creationId xmlns:a16="http://schemas.microsoft.com/office/drawing/2014/main" id="{70F988E9-550E-4EAB-9D64-8351FF5F4672}"/>
+                <a16:creationId xmlns:a16="http://schemas.microsoft.com/office/drawing/2014/main" id="{591BB038-E7D8-4436-A5AC-9E2454D65DD0}"/>
               </a:ext>
             </a:extLst>
           </p:cNvPr>
@@ -17071,7 +17071,7 @@
           <p:cNvPr id="10" name="element-92">
             <a:extLst xmlns:a="http://schemas.openxmlformats.org/drawingml/2006/main">
               <a:ext uri="{FF2B5EF4-FFF2-40B4-BE49-F238E27FC236}">
-                <a16:creationId xmlns:a16="http://schemas.microsoft.com/office/drawing/2014/main" id="{8C512943-264B-461E-8DD1-C380434D8847}"/>
+                <a16:creationId xmlns:a16="http://schemas.microsoft.com/office/drawing/2014/main" id="{F8B09733-8E85-4AEC-AF77-0952B8FDD1AA}"/>
               </a:ext>
             </a:extLst>
           </p:cNvPr>
@@ -17230,7 +17230,7 @@
           <p:cNvPr id="11" name="element-93">
             <a:extLst xmlns:a="http://schemas.openxmlformats.org/drawingml/2006/main">
               <a:ext uri="{FF2B5EF4-FFF2-40B4-BE49-F238E27FC236}">
-                <a16:creationId xmlns:a16="http://schemas.microsoft.com/office/drawing/2014/main" id="{2259793B-F4D2-4EE6-87E8-FE9E5468F7A0}"/>
+                <a16:creationId xmlns:a16="http://schemas.microsoft.com/office/drawing/2014/main" id="{AF9F070F-C02C-41EC-BEF8-528BE6A49CFD}"/>
               </a:ext>
             </a:extLst>
           </p:cNvPr>
@@ -17387,7 +17387,7 @@
     </p:spTree>
     <p:extLst>
       <p:ext uri="{BB962C8B-B14F-4D97-AF65-F5344CB8AC3E}">
-        <p14:creationId xmlns:p14="http://schemas.microsoft.com/office/powerpoint/2010/main" val="2064169809"/>
+        <p14:creationId xmlns:p14="http://schemas.microsoft.com/office/powerpoint/2010/main" val="414067938"/>
       </p:ext>
     </p:extLst>
   </p:cSld>
@@ -17418,7 +17418,7 @@
           <p:cNvPr id="14" name="element-94">
             <a:extLst xmlns:a="http://schemas.openxmlformats.org/drawingml/2006/main">
               <a:ext uri="{FF2B5EF4-FFF2-40B4-BE49-F238E27FC236}">
-                <a16:creationId xmlns:a16="http://schemas.microsoft.com/office/drawing/2014/main" id="{3765C6C7-102B-472F-874D-4A90374DA017}"/>
+                <a16:creationId xmlns:a16="http://schemas.microsoft.com/office/drawing/2014/main" id="{55A03BC5-3B72-401D-B525-0737FDA3225D}"/>
               </a:ext>
             </a:extLst>
           </p:cNvPr>
@@ -17600,7 +17600,7 @@
           <p:cNvPr id="2" name="element-95">
             <a:extLst xmlns:a="http://schemas.openxmlformats.org/drawingml/2006/main">
               <a:ext uri="{FF2B5EF4-FFF2-40B4-BE49-F238E27FC236}">
-                <a16:creationId xmlns:a16="http://schemas.microsoft.com/office/drawing/2014/main" id="{480B9A37-552E-4E97-949F-F8D1345B1C16}"/>
+                <a16:creationId xmlns:a16="http://schemas.microsoft.com/office/drawing/2014/main" id="{A43B7092-FF4D-4C83-B946-E80EB5053A95}"/>
               </a:ext>
             </a:extLst>
           </p:cNvPr>
@@ -17759,7 +17759,7 @@
           <p:cNvPr id="3" name="element-96">
             <a:extLst xmlns:a="http://schemas.openxmlformats.org/drawingml/2006/main">
               <a:ext uri="{FF2B5EF4-FFF2-40B4-BE49-F238E27FC236}">
-                <a16:creationId xmlns:a16="http://schemas.microsoft.com/office/drawing/2014/main" id="{760F577C-5B6E-4083-931F-9479F919FB8E}"/>
+                <a16:creationId xmlns:a16="http://schemas.microsoft.com/office/drawing/2014/main" id="{519DB4A0-A290-4940-B485-CB25262A16C0}"/>
               </a:ext>
             </a:extLst>
           </p:cNvPr>
@@ -17918,7 +17918,7 @@
           <p:cNvPr id="4" name="element-97">
             <a:extLst xmlns:a="http://schemas.openxmlformats.org/drawingml/2006/main">
               <a:ext uri="{FF2B5EF4-FFF2-40B4-BE49-F238E27FC236}">
-                <a16:creationId xmlns:a16="http://schemas.microsoft.com/office/drawing/2014/main" id="{78A75AD1-A573-479D-83AE-AF80751ED36F}"/>
+                <a16:creationId xmlns:a16="http://schemas.microsoft.com/office/drawing/2014/main" id="{747015AE-C273-4908-994F-BF80D6CA86EA}"/>
               </a:ext>
             </a:extLst>
           </p:cNvPr>
@@ -18077,7 +18077,7 @@
           <p:cNvPr id="5" name="element-98">
             <a:extLst xmlns:a="http://schemas.openxmlformats.org/drawingml/2006/main">
               <a:ext uri="{FF2B5EF4-FFF2-40B4-BE49-F238E27FC236}">
-                <a16:creationId xmlns:a16="http://schemas.microsoft.com/office/drawing/2014/main" id="{48D237DA-A275-4E64-AC8A-981D08E5AF0A}"/>
+                <a16:creationId xmlns:a16="http://schemas.microsoft.com/office/drawing/2014/main" id="{CD28A7C2-5D30-44CD-AEA9-D7E4CA4D0699}"/>
               </a:ext>
             </a:extLst>
           </p:cNvPr>
@@ -18236,7 +18236,7 @@
           <p:cNvPr id="6" name="element-99">
             <a:extLst xmlns:a="http://schemas.openxmlformats.org/drawingml/2006/main">
               <a:ext uri="{FF2B5EF4-FFF2-40B4-BE49-F238E27FC236}">
-                <a16:creationId xmlns:a16="http://schemas.microsoft.com/office/drawing/2014/main" id="{2DE683E6-64EA-4792-A948-C7BE78B1F9A1}"/>
+                <a16:creationId xmlns:a16="http://schemas.microsoft.com/office/drawing/2014/main" id="{8FC4F810-1DD0-439E-9811-86DEFEAAF115}"/>
               </a:ext>
             </a:extLst>
           </p:cNvPr>
@@ -18395,7 +18395,7 @@
           <p:cNvPr id="7" name="element-100">
             <a:extLst xmlns:a="http://schemas.openxmlformats.org/drawingml/2006/main">
               <a:ext uri="{FF2B5EF4-FFF2-40B4-BE49-F238E27FC236}">
-                <a16:creationId xmlns:a16="http://schemas.microsoft.com/office/drawing/2014/main" id="{51281055-B757-4BAF-834E-1A4AAC84A9D0}"/>
+                <a16:creationId xmlns:a16="http://schemas.microsoft.com/office/drawing/2014/main" id="{DAFD5AB3-6504-4382-90DC-0D7BC7D73D08}"/>
               </a:ext>
             </a:extLst>
           </p:cNvPr>
@@ -18554,7 +18554,7 @@
           <p:cNvPr id="8" name="element-101">
             <a:extLst xmlns:a="http://schemas.openxmlformats.org/drawingml/2006/main">
               <a:ext uri="{FF2B5EF4-FFF2-40B4-BE49-F238E27FC236}">
-                <a16:creationId xmlns:a16="http://schemas.microsoft.com/office/drawing/2014/main" id="{046E37AA-4102-45F8-804E-10A160BB570D}"/>
+                <a16:creationId xmlns:a16="http://schemas.microsoft.com/office/drawing/2014/main" id="{BDC4C496-37F7-4710-8B61-38484E01CCA7}"/>
               </a:ext>
             </a:extLst>
           </p:cNvPr>
@@ -18713,7 +18713,7 @@
           <p:cNvPr id="9" name="">
             <a:extLst xmlns:a="http://schemas.openxmlformats.org/drawingml/2006/main">
               <a:ext uri="{FF2B5EF4-FFF2-40B4-BE49-F238E27FC236}">
-                <a16:creationId xmlns:a16="http://schemas.microsoft.com/office/drawing/2014/main" id="{E7227CDB-21C5-4A3A-818B-CA3006746F00}"/>
+                <a16:creationId xmlns:a16="http://schemas.microsoft.com/office/drawing/2014/main" id="{74183298-B37A-46B9-B4C4-5C1CA99C16FC}"/>
               </a:ext>
             </a:extLst>
           </p:cNvPr>
@@ -19354,7 +19354,7 @@
           <p:cNvPr id="10" name="element-102">
             <a:extLst xmlns:a="http://schemas.openxmlformats.org/drawingml/2006/main">
               <a:ext uri="{FF2B5EF4-FFF2-40B4-BE49-F238E27FC236}">
-                <a16:creationId xmlns:a16="http://schemas.microsoft.com/office/drawing/2014/main" id="{82AA7802-D7B7-4E48-A831-8AD774240BFA}"/>
+                <a16:creationId xmlns:a16="http://schemas.microsoft.com/office/drawing/2014/main" id="{3BA5B13F-6AA6-4EDF-AEC4-1082D9AA8943}"/>
               </a:ext>
             </a:extLst>
           </p:cNvPr>
@@ -19513,7 +19513,7 @@
           <p:cNvPr id="11" name="element-103">
             <a:extLst xmlns:a="http://schemas.openxmlformats.org/drawingml/2006/main">
               <a:ext uri="{FF2B5EF4-FFF2-40B4-BE49-F238E27FC236}">
-                <a16:creationId xmlns:a16="http://schemas.microsoft.com/office/drawing/2014/main" id="{A192FD23-11AC-443F-A6B2-F15E2071D39C}"/>
+                <a16:creationId xmlns:a16="http://schemas.microsoft.com/office/drawing/2014/main" id="{440F8306-968F-4177-B24C-55C363D27FA1}"/>
               </a:ext>
             </a:extLst>
           </p:cNvPr>
@@ -19544,7 +19544,7 @@
           <p:cNvPr id="12" name="element-104">
             <a:extLst xmlns:a="http://schemas.openxmlformats.org/drawingml/2006/main">
               <a:ext uri="{FF2B5EF4-FFF2-40B4-BE49-F238E27FC236}">
-                <a16:creationId xmlns:a16="http://schemas.microsoft.com/office/drawing/2014/main" id="{AB7F3272-E867-4A23-B7D0-3578D782A60A}"/>
+                <a16:creationId xmlns:a16="http://schemas.microsoft.com/office/drawing/2014/main" id="{F73A3909-863B-4E8E-92BD-73A4CE6BD71B}"/>
               </a:ext>
             </a:extLst>
           </p:cNvPr>
@@ -19703,7 +19703,7 @@
           <p:cNvPr id="13" name="element-105">
             <a:extLst xmlns:a="http://schemas.openxmlformats.org/drawingml/2006/main">
               <a:ext uri="{FF2B5EF4-FFF2-40B4-BE49-F238E27FC236}">
-                <a16:creationId xmlns:a16="http://schemas.microsoft.com/office/drawing/2014/main" id="{7F8983F5-5381-47E3-967F-383A7CB29AEC}"/>
+                <a16:creationId xmlns:a16="http://schemas.microsoft.com/office/drawing/2014/main" id="{EB2359E2-0FDC-4CEE-924E-5807E5BBA464}"/>
               </a:ext>
             </a:extLst>
           </p:cNvPr>
@@ -19860,7 +19860,7 @@
     </p:spTree>
     <p:extLst>
       <p:ext uri="{BB962C8B-B14F-4D97-AF65-F5344CB8AC3E}">
-        <p14:creationId xmlns:p14="http://schemas.microsoft.com/office/powerpoint/2010/main" val="436505567"/>
+        <p14:creationId xmlns:p14="http://schemas.microsoft.com/office/powerpoint/2010/main" val="304099063"/>
       </p:ext>
     </p:extLst>
   </p:cSld>
@@ -19891,7 +19891,7 @@
           <p:cNvPr id="22" name="element-106">
             <a:extLst xmlns:a="http://schemas.openxmlformats.org/drawingml/2006/main">
               <a:ext uri="{FF2B5EF4-FFF2-40B4-BE49-F238E27FC236}">
-                <a16:creationId xmlns:a16="http://schemas.microsoft.com/office/drawing/2014/main" id="{4B4E9894-5E8D-4393-997D-D912A0F694D2}"/>
+                <a16:creationId xmlns:a16="http://schemas.microsoft.com/office/drawing/2014/main" id="{D0E7B0F1-F117-4332-8E9E-C35199434726}"/>
               </a:ext>
             </a:extLst>
           </p:cNvPr>
@@ -20040,7 +20040,7 @@
                 <a:ea typeface="TeX Gyre Schola"/>
                 <a:cs typeface="TeX Gyre Schola"/>
               </a:rPr>
-              <a:t>What we can show, and what comes next</a:t>
+              <a:t>Prototype and future scope</a:t>
             </a:r>
           </a:p>
         </p:txBody>
@@ -20050,7 +20050,7 @@
           <p:cNvPr id="2" name="element-107">
             <a:extLst xmlns:a="http://schemas.openxmlformats.org/drawingml/2006/main">
               <a:ext uri="{FF2B5EF4-FFF2-40B4-BE49-F238E27FC236}">
-                <a16:creationId xmlns:a16="http://schemas.microsoft.com/office/drawing/2014/main" id="{AE327A68-E5CA-4805-A3AF-62643C703564}"/>
+                <a16:creationId xmlns:a16="http://schemas.microsoft.com/office/drawing/2014/main" id="{5E35C354-CBE7-4EA2-AD55-CD6F2226780D}"/>
               </a:ext>
             </a:extLst>
           </p:cNvPr>
@@ -20199,7 +20199,7 @@
                 <a:ea typeface="TeX Gyre Adventor"/>
                 <a:cs typeface="TeX Gyre Adventor"/>
               </a:rPr>
-              <a:t>TEAM LINEOFCODE  ·  DTU</a:t>
+              <a:t>IN THE PROTOTYPE</a:t>
             </a:r>
           </a:p>
         </p:txBody>
@@ -20209,7 +20209,7 @@
           <p:cNvPr id="3" name="element-108">
             <a:extLst xmlns:a="http://schemas.openxmlformats.org/drawingml/2006/main">
               <a:ext uri="{FF2B5EF4-FFF2-40B4-BE49-F238E27FC236}">
-                <a16:creationId xmlns:a16="http://schemas.microsoft.com/office/drawing/2014/main" id="{B0A55B7F-06BC-4C0C-AC16-48F14167A129}"/>
+                <a16:creationId xmlns:a16="http://schemas.microsoft.com/office/drawing/2014/main" id="{7C3013EA-7700-47D5-A197-66665FE98561}"/>
               </a:ext>
             </a:extLst>
           </p:cNvPr>
@@ -20358,7 +20358,7 @@
                 <a:ea typeface="TeX Gyre Schola"/>
                 <a:cs typeface="TeX Gyre Schola"/>
               </a:rPr>
-              <a:t>Tushar Aggarwal</a:t>
+              <a:t>Journal pages</a:t>
             </a:r>
           </a:p>
         </p:txBody>
@@ -20368,7 +20368,7 @@
           <p:cNvPr id="4" name="element-109">
             <a:extLst xmlns:a="http://schemas.openxmlformats.org/drawingml/2006/main">
               <a:ext uri="{FF2B5EF4-FFF2-40B4-BE49-F238E27FC236}">
-                <a16:creationId xmlns:a16="http://schemas.microsoft.com/office/drawing/2014/main" id="{08EA89CC-8996-4DC6-A12D-E3A70CA13A25}"/>
+                <a16:creationId xmlns:a16="http://schemas.microsoft.com/office/drawing/2014/main" id="{7FAE8AF6-C73E-4DC7-8052-67971226F2D3}"/>
               </a:ext>
             </a:extLst>
           </p:cNvPr>
@@ -20517,7 +20517,7 @@
                 <a:ea typeface="TeX Gyre Adventor"/>
                 <a:cs typeface="TeX Gyre Adventor"/>
               </a:rPr>
-              <a:t>Product, integration and testing</a:t>
+              <a:t>Photos, personal notes and a life archive</a:t>
             </a:r>
           </a:p>
         </p:txBody>
@@ -20527,7 +20527,7 @@
           <p:cNvPr id="5" name="element-110">
             <a:extLst xmlns:a="http://schemas.openxmlformats.org/drawingml/2006/main">
               <a:ext uri="{FF2B5EF4-FFF2-40B4-BE49-F238E27FC236}">
-                <a16:creationId xmlns:a16="http://schemas.microsoft.com/office/drawing/2014/main" id="{C92A65A2-16D4-4EE5-B590-E230B5E17D47}"/>
+                <a16:creationId xmlns:a16="http://schemas.microsoft.com/office/drawing/2014/main" id="{C5668EC1-11FC-4FDA-B4B5-0D41EA49EAD3}"/>
               </a:ext>
             </a:extLst>
           </p:cNvPr>
@@ -20676,7 +20676,7 @@
                 <a:ea typeface="TeX Gyre Schola"/>
                 <a:cs typeface="TeX Gyre Schola"/>
               </a:rPr>
-              <a:t>Rajat Maan</a:t>
+              <a:t>Public event research</a:t>
             </a:r>
           </a:p>
         </p:txBody>
@@ -20686,7 +20686,7 @@
           <p:cNvPr id="6" name="element-111">
             <a:extLst xmlns:a="http://schemas.openxmlformats.org/drawingml/2006/main">
               <a:ext uri="{FF2B5EF4-FFF2-40B4-BE49-F238E27FC236}">
-                <a16:creationId xmlns:a16="http://schemas.microsoft.com/office/drawing/2014/main" id="{AB6966DD-A9DE-4C4D-AA68-007D986C623B}"/>
+                <a16:creationId xmlns:a16="http://schemas.microsoft.com/office/drawing/2014/main" id="{5B549A0C-9873-4A36-AC86-FC8574177F26}"/>
               </a:ext>
             </a:extLst>
           </p:cNvPr>
@@ -20835,7 +20835,7 @@
                 <a:ea typeface="TeX Gyre Adventor"/>
                 <a:cs typeface="TeX Gyre Adventor"/>
               </a:rPr>
-              <a:t>Backend and source-based answers</a:t>
+              <a:t>TinyFish reads the event website</a:t>
             </a:r>
           </a:p>
         </p:txBody>
@@ -20845,7 +20845,7 @@
           <p:cNvPr id="7" name="element-112">
             <a:extLst xmlns:a="http://schemas.openxmlformats.org/drawingml/2006/main">
               <a:ext uri="{FF2B5EF4-FFF2-40B4-BE49-F238E27FC236}">
-                <a16:creationId xmlns:a16="http://schemas.microsoft.com/office/drawing/2014/main" id="{4C086389-7638-450D-9AD3-C28ABD512D04}"/>
+                <a16:creationId xmlns:a16="http://schemas.microsoft.com/office/drawing/2014/main" id="{47E7F1A7-8986-4DC8-B8EE-C2514BBAF2FA}"/>
               </a:ext>
             </a:extLst>
           </p:cNvPr>
@@ -20994,7 +20994,7 @@
                 <a:ea typeface="TeX Gyre Schola"/>
                 <a:cs typeface="TeX Gyre Schola"/>
               </a:rPr>
-              <a:t>Shrivats Goel</a:t>
+              <a:t>Review before saving</a:t>
             </a:r>
           </a:p>
         </p:txBody>
@@ -21004,7 +21004,7 @@
           <p:cNvPr id="8" name="element-113">
             <a:extLst xmlns:a="http://schemas.openxmlformats.org/drawingml/2006/main">
               <a:ext uri="{FF2B5EF4-FFF2-40B4-BE49-F238E27FC236}">
-                <a16:creationId xmlns:a16="http://schemas.microsoft.com/office/drawing/2014/main" id="{2261E27A-393E-41F6-A167-BA179F6BDCB0}"/>
+                <a16:creationId xmlns:a16="http://schemas.microsoft.com/office/drawing/2014/main" id="{CE3CAC02-0E11-4AAB-922C-B9C4EA0268D1}"/>
               </a:ext>
             </a:extLst>
           </p:cNvPr>
@@ -21153,7 +21153,7 @@
                 <a:ea typeface="TeX Gyre Adventor"/>
                 <a:cs typeface="TeX Gyre Adventor"/>
               </a:rPr>
-              <a:t>TinyFish workflow and failure handling</a:t>
+              <a:t>Only approved facts enter the draft</a:t>
             </a:r>
           </a:p>
         </p:txBody>
@@ -21163,7 +21163,7 @@
           <p:cNvPr id="9" name="element-114">
             <a:extLst xmlns:a="http://schemas.openxmlformats.org/drawingml/2006/main">
               <a:ext uri="{FF2B5EF4-FFF2-40B4-BE49-F238E27FC236}">
-                <a16:creationId xmlns:a16="http://schemas.microsoft.com/office/drawing/2014/main" id="{3D606526-A66E-4816-B947-618B3000F0ED}"/>
+                <a16:creationId xmlns:a16="http://schemas.microsoft.com/office/drawing/2014/main" id="{7F9BCDF1-46BF-4B05-A2B0-A196B1155E22}"/>
               </a:ext>
             </a:extLst>
           </p:cNvPr>
@@ -21312,7 +21312,7 @@
                 <a:ea typeface="TeX Gyre Schola"/>
                 <a:cs typeface="TeX Gyre Schola"/>
               </a:rPr>
-              <a:t>Vanshika Pasi</a:t>
+              <a:t>Source provenance</a:t>
             </a:r>
           </a:p>
         </p:txBody>
@@ -21322,7 +21322,7 @@
           <p:cNvPr id="10" name="element-115">
             <a:extLst xmlns:a="http://schemas.openxmlformats.org/drawingml/2006/main">
               <a:ext uri="{FF2B5EF4-FFF2-40B4-BE49-F238E27FC236}">
-                <a16:creationId xmlns:a16="http://schemas.microsoft.com/office/drawing/2014/main" id="{4B73417E-0E3F-49B4-AE47-F582548CC054}"/>
+                <a16:creationId xmlns:a16="http://schemas.microsoft.com/office/drawing/2014/main" id="{DAA8760D-4918-4D1A-8FB1-9FD4C7615D59}"/>
               </a:ext>
             </a:extLst>
           </p:cNvPr>
@@ -21471,7 +21471,7 @@
                 <a:ea typeface="TeX Gyre Adventor"/>
                 <a:cs typeface="TeX Gyre Adventor"/>
               </a:rPr>
-              <a:t>Design, editor and review experience</a:t>
+              <a:t>Event links and retrieval time stay visible</a:t>
             </a:r>
           </a:p>
         </p:txBody>
@@ -21481,7 +21481,7 @@
           <p:cNvPr id="11" name="element-116">
             <a:extLst xmlns:a="http://schemas.openxmlformats.org/drawingml/2006/main">
               <a:ext uri="{FF2B5EF4-FFF2-40B4-BE49-F238E27FC236}">
-                <a16:creationId xmlns:a16="http://schemas.microsoft.com/office/drawing/2014/main" id="{8A0FA1EC-36B4-4E2F-AE5C-B3D26662A274}"/>
+                <a16:creationId xmlns:a16="http://schemas.microsoft.com/office/drawing/2014/main" id="{F2D9344C-C7FA-4557-A6C0-0ABB4F35B0D4}"/>
               </a:ext>
             </a:extLst>
           </p:cNvPr>
@@ -21640,7 +21640,7 @@
           <p:cNvPr id="12" name="element-117">
             <a:extLst xmlns:a="http://schemas.openxmlformats.org/drawingml/2006/main">
               <a:ext uri="{FF2B5EF4-FFF2-40B4-BE49-F238E27FC236}">
-                <a16:creationId xmlns:a16="http://schemas.microsoft.com/office/drawing/2014/main" id="{950DD620-697E-40E6-8FFA-DF178F349698}"/>
+                <a16:creationId xmlns:a16="http://schemas.microsoft.com/office/drawing/2014/main" id="{04EBEBDA-E521-4B4E-8E0E-1AB5CA5F472E}"/>
               </a:ext>
             </a:extLst>
           </p:cNvPr>
@@ -21789,7 +21789,7 @@
                 <a:ea typeface="TeX Gyre Schola"/>
                 <a:cs typeface="TeX Gyre Schola"/>
               </a:rPr>
-              <a:t>85</a:t>
+              <a:t>86</a:t>
             </a:r>
           </a:p>
         </p:txBody>
@@ -21799,7 +21799,7 @@
           <p:cNvPr id="13" name="element-118">
             <a:extLst xmlns:a="http://schemas.openxmlformats.org/drawingml/2006/main">
               <a:ext uri="{FF2B5EF4-FFF2-40B4-BE49-F238E27FC236}">
-                <a16:creationId xmlns:a16="http://schemas.microsoft.com/office/drawing/2014/main" id="{1BCF8E36-CB33-49CF-9191-371CEE3D0D85}"/>
+                <a16:creationId xmlns:a16="http://schemas.microsoft.com/office/drawing/2014/main" id="{E912BE15-807D-4BF3-A611-2AD5F3F7F9FB}"/>
               </a:ext>
             </a:extLst>
           </p:cNvPr>
@@ -21981,7 +21981,7 @@
           <p:cNvPr id="14" name="element-119">
             <a:extLst xmlns:a="http://schemas.openxmlformats.org/drawingml/2006/main">
               <a:ext uri="{FF2B5EF4-FFF2-40B4-BE49-F238E27FC236}">
-                <a16:creationId xmlns:a16="http://schemas.microsoft.com/office/drawing/2014/main" id="{34A024B8-2EA5-444D-838D-211A2CA2014A}"/>
+                <a16:creationId xmlns:a16="http://schemas.microsoft.com/office/drawing/2014/main" id="{9CABC61A-7394-4F53-BD74-AA863FBBDE3E}"/>
               </a:ext>
             </a:extLst>
           </p:cNvPr>
@@ -22140,7 +22140,7 @@
           <p:cNvPr id="15" name="element-120">
             <a:extLst xmlns:a="http://schemas.openxmlformats.org/drawingml/2006/main">
               <a:ext uri="{FF2B5EF4-FFF2-40B4-BE49-F238E27FC236}">
-                <a16:creationId xmlns:a16="http://schemas.microsoft.com/office/drawing/2014/main" id="{057B50EB-0556-4A3A-87BF-C2AB5C8312B4}"/>
+                <a16:creationId xmlns:a16="http://schemas.microsoft.com/office/drawing/2014/main" id="{60752E95-16C8-4BAD-942C-3071AFE1228C}"/>
               </a:ext>
             </a:extLst>
           </p:cNvPr>
@@ -22312,7 +22312,7 @@
                 <a:ea typeface="TeX Gyre Adventor"/>
                 <a:cs typeface="TeX Gyre Adventor"/>
               </a:rPr>
-              <a:t>Hosted save/reopen remains to verify</a:t>
+              <a:t>Recorded result included in the repository</a:t>
             </a:r>
           </a:p>
         </p:txBody>
@@ -22322,7 +22322,7 @@
           <p:cNvPr id="16" name="element-121">
             <a:extLst xmlns:a="http://schemas.openxmlformats.org/drawingml/2006/main">
               <a:ext uri="{FF2B5EF4-FFF2-40B4-BE49-F238E27FC236}">
-                <a16:creationId xmlns:a16="http://schemas.microsoft.com/office/drawing/2014/main" id="{4DE1994D-BA18-4B72-AA3B-167E864BAA1F}"/>
+                <a16:creationId xmlns:a16="http://schemas.microsoft.com/office/drawing/2014/main" id="{09A12D49-794B-4D57-8260-8ED1CCD7856F}"/>
               </a:ext>
             </a:extLst>
           </p:cNvPr>
@@ -22353,7 +22353,7 @@
           <p:cNvPr id="17" name="element-122">
             <a:extLst xmlns:a="http://schemas.openxmlformats.org/drawingml/2006/main">
               <a:ext uri="{FF2B5EF4-FFF2-40B4-BE49-F238E27FC236}">
-                <a16:creationId xmlns:a16="http://schemas.microsoft.com/office/drawing/2014/main" id="{382AC9BF-29B7-49F9-BAD4-0EE8854266C2}"/>
+                <a16:creationId xmlns:a16="http://schemas.microsoft.com/office/drawing/2014/main" id="{83C8285E-83A9-4123-AB6D-6E1DD1524615}"/>
               </a:ext>
             </a:extLst>
           </p:cNvPr>
@@ -22512,7 +22512,7 @@
           <p:cNvPr id="18" name="element-123">
             <a:extLst xmlns:a="http://schemas.openxmlformats.org/drawingml/2006/main">
               <a:ext uri="{FF2B5EF4-FFF2-40B4-BE49-F238E27FC236}">
-                <a16:creationId xmlns:a16="http://schemas.microsoft.com/office/drawing/2014/main" id="{798823E3-A465-4C76-8BF9-DD71B8227351}"/>
+                <a16:creationId xmlns:a16="http://schemas.microsoft.com/office/drawing/2014/main" id="{D6FD6EE2-8A44-43A5-AC5B-3884161CB302}"/>
               </a:ext>
             </a:extLst>
           </p:cNvPr>
@@ -22661,7 +22661,7 @@
                 <a:ea typeface="TeX Gyre Adventor"/>
                 <a:cs typeface="TeX Gyre Adventor"/>
               </a:rPr>
-              <a:t>Verify the isolated host end to end. Then test better memory retrieval, voice and selected imports.</a:t>
+              <a:t>Pilot with 20 adult users. Improve memory retrieval, then evaluate voice and selected media imports.</a:t>
             </a:r>
           </a:p>
         </p:txBody>
@@ -22671,7 +22671,7 @@
           <p:cNvPr id="19" name="element-124">
             <a:extLst xmlns:a="http://schemas.openxmlformats.org/drawingml/2006/main">
               <a:ext uri="{FF2B5EF4-FFF2-40B4-BE49-F238E27FC236}">
-                <a16:creationId xmlns:a16="http://schemas.microsoft.com/office/drawing/2014/main" id="{8E7DEFBC-CE0F-46A9-B2D5-28D80EA6633A}"/>
+                <a16:creationId xmlns:a16="http://schemas.microsoft.com/office/drawing/2014/main" id="{1196EFC4-AA16-4B16-86F6-4EB7469DE72E}"/>
               </a:ext>
             </a:extLst>
           </p:cNvPr>
@@ -22830,7 +22830,7 @@
           <p:cNvPr id="20" name="element-125">
             <a:extLst xmlns:a="http://schemas.openxmlformats.org/drawingml/2006/main">
               <a:ext uri="{FF2B5EF4-FFF2-40B4-BE49-F238E27FC236}">
-                <a16:creationId xmlns:a16="http://schemas.microsoft.com/office/drawing/2014/main" id="{DB890BC7-F9C0-4F7E-BDBD-BEC014A2DF55}"/>
+                <a16:creationId xmlns:a16="http://schemas.microsoft.com/office/drawing/2014/main" id="{FBEBA13D-404C-4F62-A1B2-7355F8447777}"/>
               </a:ext>
             </a:extLst>
           </p:cNvPr>
@@ -22979,7 +22979,7 @@
                 <a:ea typeface="TeX Gyre Adventor"/>
                 <a:cs typeface="TeX Gyre Adventor"/>
               </a:rPr>
-              <a:t>Integrated B.Sc. M.Sc. in Data Science</a:t>
+              <a:t>Team LineOfCode  ·  DTU</a:t>
             </a:r>
           </a:p>
         </p:txBody>
@@ -22989,7 +22989,7 @@
           <p:cNvPr id="21" name="element-126">
             <a:extLst xmlns:a="http://schemas.openxmlformats.org/drawingml/2006/main">
               <a:ext uri="{FF2B5EF4-FFF2-40B4-BE49-F238E27FC236}">
-                <a16:creationId xmlns:a16="http://schemas.microsoft.com/office/drawing/2014/main" id="{9FCE6E11-35ED-409A-BC25-224B1EE335C2}"/>
+                <a16:creationId xmlns:a16="http://schemas.microsoft.com/office/drawing/2014/main" id="{575F07BE-2807-4344-A24B-34509E3009D2}"/>
               </a:ext>
             </a:extLst>
           </p:cNvPr>
@@ -23146,7 +23146,7 @@
     </p:spTree>
     <p:extLst>
       <p:ext uri="{BB962C8B-B14F-4D97-AF65-F5344CB8AC3E}">
-        <p14:creationId xmlns:p14="http://schemas.microsoft.com/office/powerpoint/2010/main" val="1151819338"/>
+        <p14:creationId xmlns:p14="http://schemas.microsoft.com/office/powerpoint/2010/main" val="2003675898"/>
       </p:ext>
     </p:extLst>
   </p:cSld>

</xml_diff>